<commit_message>
Add brand template support
Configs can set deck.template to build on a .pptx/.potx from templates/,
using its layouts, placeholders, theme colours and fonts. An optional
profile next to the template maps slide types to layouts and placeholder
roles; without one, layouts are guessed by name. Slides can also pick any
layout and fill its placeholders directly. Adds `deckgen layouts` to list
a template's placeholders and a branded demo config.

Template files are git-ignored so brand assets stay out of the repo.

Co-Authored-By: Claude Opus 5.5 <noreply@anthropic.com>
</commit_message>
<xml_diff>
--- a/out/demo.pptx
+++ b/out/demo.pptx
@@ -5508,7 +5508,7 @@
           <a:lstStyle/>
           <a:p>
             <a:r>
-              <a:rPr sz="2000" b="0">
+              <a:rPr sz="2000">
                 <a:solidFill>
                   <a:srgbClr val="D0D7E1"/>
                 </a:solidFill>
@@ -5593,8 +5593,9 @@
           </a:bodyPr>
           <a:lstStyle/>
           <a:p>
-            <a:r>
-              <a:rPr sz="1500" b="0">
+            <a:pPr algn="l"/>
+            <a:r>
+              <a:rPr sz="1500">
                 <a:solidFill>
                   <a:srgbClr val="6C757D"/>
                 </a:solidFill>
@@ -5627,8 +5628,9 @@
           </a:bodyPr>
           <a:lstStyle/>
           <a:p>
-            <a:r>
-              <a:rPr sz="1000" b="0">
+            <a:pPr algn="l"/>
+            <a:r>
+              <a:rPr sz="1000">
                 <a:solidFill>
                   <a:srgbClr val="6C757D"/>
                 </a:solidFill>
@@ -5663,7 +5665,7 @@
           <a:p>
             <a:pPr algn="r"/>
             <a:r>
-              <a:rPr sz="1000" b="0">
+              <a:rPr sz="1000">
                 <a:solidFill>
                   <a:srgbClr val="6C757D"/>
                 </a:solidFill>
@@ -5740,7 +5742,7 @@
               <a:buChar char="•"/>
             </a:pPr>
             <a:r>
-              <a:rPr sz="1600" b="0">
+              <a:rPr sz="1600">
                 <a:solidFill>
                   <a:srgbClr val="2B2D42"/>
                 </a:solidFill>
@@ -5758,7 +5760,7 @@
               <a:t>above target</a:t>
             </a:r>
             <a:r>
-              <a:rPr sz="1600" b="0">
+              <a:rPr sz="1600">
                 <a:solidFill>
                   <a:srgbClr val="2B2D42"/>
                 </a:solidFill>
@@ -5778,7 +5780,7 @@
               <a:buChar char="•"/>
             </a:pPr>
             <a:r>
-              <a:rPr sz="1600" b="0">
+              <a:rPr sz="1600">
                 <a:solidFill>
                   <a:srgbClr val="2B2D42"/>
                 </a:solidFill>
@@ -5807,7 +5809,7 @@
               <a:buChar char="•"/>
             </a:pPr>
             <a:r>
-              <a:rPr sz="1600" b="0">
+              <a:rPr sz="1600">
                 <a:solidFill>
                   <a:srgbClr val="2B2D42"/>
                 </a:solidFill>
@@ -5825,7 +5827,7 @@
               <a:t>volume-led</a:t>
             </a:r>
             <a:r>
-              <a:rPr sz="1600" b="0">
+              <a:rPr sz="1600">
                 <a:solidFill>
                   <a:srgbClr val="2B2D42"/>
                 </a:solidFill>
@@ -5904,7 +5906,7 @@
           <a:lstStyle/>
           <a:p>
             <a:r>
-              <a:rPr sz="1200" b="0">
+              <a:rPr sz="1200">
                 <a:solidFill>
                   <a:srgbClr val="6C757D"/>
                 </a:solidFill>
@@ -5994,7 +5996,7 @@
           <a:lstStyle/>
           <a:p>
             <a:r>
-              <a:rPr sz="1200" b="0">
+              <a:rPr sz="1200">
                 <a:solidFill>
                   <a:srgbClr val="6C757D"/>
                 </a:solidFill>
@@ -6084,7 +6086,7 @@
           <a:lstStyle/>
           <a:p>
             <a:r>
-              <a:rPr sz="1200" b="0">
+              <a:rPr sz="1200">
                 <a:solidFill>
                   <a:srgbClr val="6C757D"/>
                 </a:solidFill>
@@ -6106,7 +6108,7 @@
           </a:p>
           <a:p>
             <a:r>
-              <a:rPr sz="1200" b="0">
+              <a:rPr sz="1200">
                 <a:solidFill>
                   <a:srgbClr val="2A9D8F"/>
                 </a:solidFill>
@@ -6185,7 +6187,7 @@
           <a:lstStyle/>
           <a:p>
             <a:r>
-              <a:rPr sz="1200" b="0">
+              <a:rPr sz="1200">
                 <a:solidFill>
                   <a:srgbClr val="6C757D"/>
                 </a:solidFill>
@@ -6207,7 +6209,7 @@
           </a:p>
           <a:p>
             <a:r>
-              <a:rPr sz="1200" b="0">
+              <a:rPr sz="1200">
                 <a:solidFill>
                   <a:srgbClr val="D1495B"/>
                 </a:solidFill>
@@ -6292,8 +6294,9 @@
           </a:bodyPr>
           <a:lstStyle/>
           <a:p>
-            <a:r>
-              <a:rPr sz="1000" b="0">
+            <a:pPr algn="l"/>
+            <a:r>
+              <a:rPr sz="1000">
                 <a:solidFill>
                   <a:srgbClr val="6C757D"/>
                 </a:solidFill>
@@ -6328,7 +6331,7 @@
           <a:p>
             <a:pPr algn="r"/>
             <a:r>
-              <a:rPr sz="1000" b="0">
+              <a:rPr sz="1000">
                 <a:solidFill>
                   <a:srgbClr val="6C757D"/>
                 </a:solidFill>
@@ -6371,7 +6374,7 @@
               <a:buAutoNum type="arabicPeriod"/>
             </a:pPr>
             <a:r>
-              <a:rPr sz="1600" b="0">
+              <a:rPr sz="1600">
                 <a:solidFill>
                   <a:srgbClr val="2B2D42"/>
                 </a:solidFill>
@@ -6389,7 +6392,7 @@
               <a:t>$875K</a:t>
             </a:r>
             <a:r>
-              <a:rPr sz="1600" b="0">
+              <a:rPr sz="1600">
                 <a:solidFill>
                   <a:srgbClr val="2B2D42"/>
                 </a:solidFill>
@@ -6409,7 +6412,7 @@
               <a:buAutoNum type="arabicPeriod"/>
             </a:pPr>
             <a:r>
-              <a:rPr sz="1600" b="0">
+              <a:rPr sz="1600">
                 <a:solidFill>
                   <a:srgbClr val="2B2D42"/>
                 </a:solidFill>
@@ -6427,7 +6430,7 @@
               <a:t>36%</a:t>
             </a:r>
             <a:r>
-              <a:rPr sz="1600" b="0">
+              <a:rPr sz="1600">
                 <a:solidFill>
                   <a:srgbClr val="2B2D42"/>
                 </a:solidFill>
@@ -6447,7 +6450,7 @@
               <a:buAutoNum type="arabicPeriod"/>
             </a:pPr>
             <a:r>
-              <a:rPr sz="1600" b="0">
+              <a:rPr sz="1600">
                 <a:solidFill>
                   <a:srgbClr val="2B2D42"/>
                 </a:solidFill>
@@ -6550,8 +6553,9 @@
           </a:bodyPr>
           <a:lstStyle/>
           <a:p>
-            <a:r>
-              <a:rPr sz="1000" b="0">
+            <a:pPr algn="l"/>
+            <a:r>
+              <a:rPr sz="1000">
                 <a:solidFill>
                   <a:srgbClr val="6C757D"/>
                 </a:solidFill>
@@ -6586,7 +6590,7 @@
           <a:p>
             <a:pPr algn="r"/>
             <a:r>
-              <a:rPr sz="1000" b="0">
+              <a:rPr sz="1000">
                 <a:solidFill>
                   <a:srgbClr val="6C757D"/>
                 </a:solidFill>
@@ -6778,7 +6782,7 @@
               <a:t>Takeaway:</a:t>
             </a:r>
             <a:r>
-              <a:rPr sz="1600" b="0">
+              <a:rPr sz="1600">
                 <a:solidFill>
                   <a:srgbClr val="2B2D42"/>
                 </a:solidFill>
@@ -6915,7 +6919,7 @@
           <a:lstStyle/>
           <a:p>
             <a:r>
-              <a:rPr sz="2000" b="0">
+              <a:rPr sz="2000">
                 <a:solidFill>
                   <a:srgbClr val="6C757D"/>
                 </a:solidFill>
@@ -7000,8 +7004,9 @@
           </a:bodyPr>
           <a:lstStyle/>
           <a:p>
-            <a:r>
-              <a:rPr sz="1000" b="0">
+            <a:pPr algn="l"/>
+            <a:r>
+              <a:rPr sz="1000">
                 <a:solidFill>
                   <a:srgbClr val="6C757D"/>
                 </a:solidFill>
@@ -7036,7 +7041,7 @@
           <a:p>
             <a:pPr algn="r"/>
             <a:r>
-              <a:rPr sz="1000" b="0">
+              <a:rPr sz="1000">
                 <a:solidFill>
                   <a:srgbClr val="6C757D"/>
                 </a:solidFill>
@@ -7285,7 +7290,7 @@
                     <a:p>
                       <a:pPr algn="l"/>
                       <a:r>
-                        <a:rPr sz="1200" b="0">
+                        <a:rPr sz="1200">
                           <a:solidFill>
                             <a:srgbClr val="2B2D42"/>
                           </a:solidFill>
@@ -7308,7 +7313,7 @@
                     <a:p>
                       <a:pPr algn="l"/>
                       <a:r>
-                        <a:rPr sz="1200" b="0">
+                        <a:rPr sz="1200">
                           <a:solidFill>
                             <a:srgbClr val="2B2D42"/>
                           </a:solidFill>
@@ -7331,7 +7336,7 @@
                     <a:p>
                       <a:pPr algn="r"/>
                       <a:r>
-                        <a:rPr sz="1200" b="0">
+                        <a:rPr sz="1200">
                           <a:solidFill>
                             <a:srgbClr val="2B2D42"/>
                           </a:solidFill>
@@ -7354,7 +7359,7 @@
                     <a:p>
                       <a:pPr algn="r"/>
                       <a:r>
-                        <a:rPr sz="1200" b="0">
+                        <a:rPr sz="1200">
                           <a:solidFill>
                             <a:srgbClr val="2B2D42"/>
                           </a:solidFill>
@@ -7379,7 +7384,7 @@
                     <a:p>
                       <a:pPr algn="l"/>
                       <a:r>
-                        <a:rPr sz="1200" b="0">
+                        <a:rPr sz="1200">
                           <a:solidFill>
                             <a:srgbClr val="2B2D42"/>
                           </a:solidFill>
@@ -7402,7 +7407,7 @@
                     <a:p>
                       <a:pPr algn="l"/>
                       <a:r>
-                        <a:rPr sz="1200" b="0">
+                        <a:rPr sz="1200">
                           <a:solidFill>
                             <a:srgbClr val="2B2D42"/>
                           </a:solidFill>
@@ -7425,7 +7430,7 @@
                     <a:p>
                       <a:pPr algn="r"/>
                       <a:r>
-                        <a:rPr sz="1200" b="0">
+                        <a:rPr sz="1200">
                           <a:solidFill>
                             <a:srgbClr val="2B2D42"/>
                           </a:solidFill>
@@ -7448,7 +7453,7 @@
                     <a:p>
                       <a:pPr algn="r"/>
                       <a:r>
-                        <a:rPr sz="1200" b="0">
+                        <a:rPr sz="1200">
                           <a:solidFill>
                             <a:srgbClr val="2B2D42"/>
                           </a:solidFill>
@@ -7473,7 +7478,7 @@
                     <a:p>
                       <a:pPr algn="l"/>
                       <a:r>
-                        <a:rPr sz="1200" b="0">
+                        <a:rPr sz="1200">
                           <a:solidFill>
                             <a:srgbClr val="2B2D42"/>
                           </a:solidFill>
@@ -7496,7 +7501,7 @@
                     <a:p>
                       <a:pPr algn="l"/>
                       <a:r>
-                        <a:rPr sz="1200" b="0">
+                        <a:rPr sz="1200">
                           <a:solidFill>
                             <a:srgbClr val="2B2D42"/>
                           </a:solidFill>
@@ -7519,7 +7524,7 @@
                     <a:p>
                       <a:pPr algn="r"/>
                       <a:r>
-                        <a:rPr sz="1200" b="0">
+                        <a:rPr sz="1200">
                           <a:solidFill>
                             <a:srgbClr val="2B2D42"/>
                           </a:solidFill>
@@ -7542,7 +7547,7 @@
                     <a:p>
                       <a:pPr algn="r"/>
                       <a:r>
-                        <a:rPr sz="1200" b="0">
+                        <a:rPr sz="1200">
                           <a:solidFill>
                             <a:srgbClr val="2B2D42"/>
                           </a:solidFill>
@@ -7567,7 +7572,7 @@
                     <a:p>
                       <a:pPr algn="l"/>
                       <a:r>
-                        <a:rPr sz="1200" b="0">
+                        <a:rPr sz="1200">
                           <a:solidFill>
                             <a:srgbClr val="2B2D42"/>
                           </a:solidFill>
@@ -7590,7 +7595,7 @@
                     <a:p>
                       <a:pPr algn="l"/>
                       <a:r>
-                        <a:rPr sz="1200" b="0">
+                        <a:rPr sz="1200">
                           <a:solidFill>
                             <a:srgbClr val="2B2D42"/>
                           </a:solidFill>
@@ -7613,7 +7618,7 @@
                     <a:p>
                       <a:pPr algn="r"/>
                       <a:r>
-                        <a:rPr sz="1200" b="0">
+                        <a:rPr sz="1200">
                           <a:solidFill>
                             <a:srgbClr val="2B2D42"/>
                           </a:solidFill>
@@ -7636,7 +7641,7 @@
                     <a:p>
                       <a:pPr algn="r"/>
                       <a:r>
-                        <a:rPr sz="1200" b="0">
+                        <a:rPr sz="1200">
                           <a:solidFill>
                             <a:srgbClr val="2B2D42"/>
                           </a:solidFill>
@@ -7661,7 +7666,7 @@
                     <a:p>
                       <a:pPr algn="l"/>
                       <a:r>
-                        <a:rPr sz="1200" b="0">
+                        <a:rPr sz="1200">
                           <a:solidFill>
                             <a:srgbClr val="2B2D42"/>
                           </a:solidFill>
@@ -7684,7 +7689,7 @@
                     <a:p>
                       <a:pPr algn="l"/>
                       <a:r>
-                        <a:rPr sz="1200" b="0">
+                        <a:rPr sz="1200">
                           <a:solidFill>
                             <a:srgbClr val="2B2D42"/>
                           </a:solidFill>
@@ -7707,7 +7712,7 @@
                     <a:p>
                       <a:pPr algn="r"/>
                       <a:r>
-                        <a:rPr sz="1200" b="0">
+                        <a:rPr sz="1200">
                           <a:solidFill>
                             <a:srgbClr val="2B2D42"/>
                           </a:solidFill>
@@ -7730,7 +7735,7 @@
                     <a:p>
                       <a:pPr algn="r"/>
                       <a:r>
-                        <a:rPr sz="1200" b="0">
+                        <a:rPr sz="1200">
                           <a:solidFill>
                             <a:srgbClr val="2B2D42"/>
                           </a:solidFill>
@@ -7825,8 +7830,9 @@
           </a:bodyPr>
           <a:lstStyle/>
           <a:p>
-            <a:r>
-              <a:rPr sz="1500" b="0">
+            <a:pPr algn="l"/>
+            <a:r>
+              <a:rPr sz="1500">
                 <a:solidFill>
                   <a:srgbClr val="6C757D"/>
                 </a:solidFill>
@@ -7861,7 +7867,7 @@
           <a:p>
             <a:pPr algn="r"/>
             <a:r>
-              <a:rPr sz="1000" b="0">
+              <a:rPr sz="1000">
                 <a:solidFill>
                   <a:srgbClr val="6C757D"/>
                 </a:solidFill>
@@ -7940,7 +7946,7 @@
           <a:lstStyle/>
           <a:p>
             <a:r>
-              <a:rPr sz="1200" b="0">
+              <a:rPr sz="1200">
                 <a:solidFill>
                   <a:srgbClr val="6C757D"/>
                 </a:solidFill>
@@ -7994,7 +8000,7 @@
               <a:buChar char="•"/>
             </a:pPr>
             <a:r>
-              <a:rPr sz="1600" b="0">
+              <a:rPr sz="1600">
                 <a:solidFill>
                   <a:srgbClr val="2B2D42"/>
                 </a:solidFill>
@@ -8012,7 +8018,7 @@
               <a:t>4.0x</a:t>
             </a:r>
             <a:r>
-              <a:rPr sz="1600" b="0">
+              <a:rPr sz="1600">
                 <a:solidFill>
                   <a:srgbClr val="2B2D42"/>
                 </a:solidFill>
@@ -8032,7 +8038,7 @@
               <a:buChar char="•"/>
             </a:pPr>
             <a:r>
-              <a:rPr sz="1600" b="0">
+              <a:rPr sz="1600">
                 <a:solidFill>
                   <a:srgbClr val="2B2D42"/>
                 </a:solidFill>
@@ -8146,7 +8152,7 @@
           <a:p>
             <a:pPr algn="r"/>
             <a:r>
-              <a:rPr sz="1000" b="0">
+              <a:rPr sz="1000">
                 <a:solidFill>
                   <a:srgbClr val="6C757D"/>
                 </a:solidFill>
@@ -8251,7 +8257,7 @@
           <a:p>
             <a:pPr algn="r"/>
             <a:r>
-              <a:rPr sz="1000" b="0">
+              <a:rPr sz="1000">
                 <a:solidFill>
                   <a:srgbClr val="6C757D"/>
                 </a:solidFill>
@@ -8396,7 +8402,7 @@
               <a:buChar char="•"/>
             </a:pPr>
             <a:r>
-              <a:rPr sz="2200" b="0">
+              <a:rPr sz="2200">
                 <a:solidFill>
                   <a:srgbClr val="2B2D42"/>
                 </a:solidFill>
@@ -8414,7 +8420,7 @@
               <a:t>15%</a:t>
             </a:r>
             <a:r>
-              <a:rPr sz="2200" b="0">
+              <a:rPr sz="2200">
                 <a:solidFill>
                   <a:srgbClr val="2B2D42"/>
                 </a:solidFill>
@@ -8434,7 +8440,7 @@
               <a:buChar char="•"/>
             </a:pPr>
             <a:r>
-              <a:rPr sz="2200" b="0">
+              <a:rPr sz="2200">
                 <a:solidFill>
                   <a:srgbClr val="2B2D42"/>
                 </a:solidFill>
@@ -8454,7 +8460,7 @@
               <a:buChar char="•"/>
             </a:pPr>
             <a:r>
-              <a:rPr sz="2200" b="0">
+              <a:rPr sz="2200">
                 <a:solidFill>
                   <a:srgbClr val="2B2D42"/>
                 </a:solidFill>

</xml_diff>

<commit_message>
Add design components, chart emphasis and slide styling
Charts: highlight, direct_labels, reference lines, and combo, waterfall
and 100% stacked kinds. Cards: kpis styles (accent/outline/dark), icons
and notes; any component can sit on a panel. Slides: per-slide background
with automatic dark-mode colours, eyebrow kickers, section numerals, a
footer with chapter and progress bar, decorated title slides. New
components: agenda, timeline, cycle (lifecycle), progress and quote.

Also fixes pie/doughnut labels showing value and percentage together.
The demos use the new features and the README documents every key.

Co-Authored-By: Claude Opus 5.5 <noreply@anthropic.com>
</commit_message>
<xml_diff>
--- a/out/demo.pptx
+++ b/out/demo.pptx
@@ -121,9 +121,9 @@
   <c:chart>
     <c:autoTitleDeleted val="1"/>
     <c:plotArea>
-      <c:lineChart>
-        <c:grouping val="standard"/>
-        <c:varyColors val="0"/>
+      <c:barChart>
+        <c:barDir val="col"/>
+        <c:grouping val="clustered"/>
         <c:ser>
           <c:idx val="0"/>
           <c:order val="0"/>
@@ -139,24 +139,10 @@
             </c:strRef>
           </c:tx>
           <c:spPr>
-            <a:ln w="28575">
-              <a:solidFill>
-                <a:srgbClr val="1F3A5F"/>
-              </a:solidFill>
-            </a:ln>
+            <a:solidFill>
+              <a:srgbClr val="1F3A5F"/>
+            </a:solidFill>
           </c:spPr>
-          <c:marker>
-            <c:spPr>
-              <a:solidFill>
-                <a:srgbClr val="1F3A5F"/>
-              </a:solidFill>
-              <a:ln>
-                <a:solidFill>
-                  <a:srgbClr val="1F3A5F"/>
-                </a:solidFill>
-              </a:ln>
-            </c:spPr>
-          </c:marker>
           <c:cat>
             <c:strRef>
               <c:f>Sheet1!$A$2:$A$13</c:f>
@@ -246,8 +232,14 @@
               </c:numCache>
             </c:numRef>
           </c:val>
-          <c:smooth val="0"/>
         </c:ser>
+        <c:gapWidth val="60"/>
+        <c:axId val="-2068027336"/>
+        <c:axId val="-2113994440"/>
+      </c:barChart>
+      <c:lineChart>
+        <c:grouping val="standard"/>
+        <c:varyColors val="0"/>
         <c:ser>
           <c:idx val="1"/>
           <c:order val="1"/>
@@ -373,12 +365,11 @@
           <c:smooth val="0"/>
         </c:ser>
         <c:marker val="1"/>
-        <c:smooth val="0"/>
-        <c:axId val="2118791784"/>
-        <c:axId val="2140495176"/>
+        <c:axId val="-2068027336"/>
+        <c:axId val="-2113994440"/>
       </c:lineChart>
       <c:catAx>
-        <c:axId val="2118791784"/>
+        <c:axId val="-2068027336"/>
         <c:scaling>
           <c:orientation val="minMax"/>
         </c:scaling>
@@ -394,7 +385,7 @@
             </a:solidFill>
           </a:ln>
         </c:spPr>
-        <c:crossAx val="2140495176"/>
+        <c:crossAx val="-2113994440"/>
         <c:crosses val="autoZero"/>
         <c:auto val="1"/>
         <c:lblAlgn val="ctr"/>
@@ -402,7 +393,7 @@
         <c:noMultiLvlLbl val="0"/>
       </c:catAx>
       <c:valAx>
-        <c:axId val="2140495176"/>
+        <c:axId val="-2113994440"/>
         <c:scaling/>
         <c:delete val="0"/>
         <c:axPos val="l"/>
@@ -410,7 +401,7 @@
           <c:spPr>
             <a:ln>
               <a:solidFill>
-                <a:srgbClr val="F1F4F8"/>
+                <a:srgbClr val="DBE0E7"/>
               </a:solidFill>
             </a:ln>
           </c:spPr>
@@ -424,18 +415,15 @@
             <a:noFill/>
           </a:ln>
         </c:spPr>
-        <c:crossAx val="2118791784"/>
+        <c:crossAx val="-2068027336"/>
         <c:crosses val="autoZero"/>
       </c:valAx>
     </c:plotArea>
     <c:legend>
       <c:legendPos val="b"/>
-      <c:layout/>
       <c:overlay val="0"/>
     </c:legend>
-    <c:plotVisOnly val="1"/>
     <c:dispBlanksAs val="gap"/>
-    <c:showDLblsOverMax val="0"/>
   </c:chart>
   <c:txPr>
     <a:bodyPr/>
@@ -707,7 +695,7 @@
           <c:spPr>
             <a:ln>
               <a:solidFill>
-                <a:srgbClr val="F1F4F8"/>
+                <a:srgbClr val="DBE0E7"/>
               </a:solidFill>
             </a:ln>
           </c:spPr>
@@ -800,6 +788,30 @@
               <a:srgbClr val="1F3A5F"/>
             </a:solidFill>
           </c:spPr>
+          <c:dPt>
+            <c:idx val="0"/>
+            <c:spPr>
+              <a:solidFill>
+                <a:srgbClr val="E07A5F"/>
+              </a:solidFill>
+            </c:spPr>
+          </c:dPt>
+          <c:dPt>
+            <c:idx val="1"/>
+            <c:spPr>
+              <a:solidFill>
+                <a:srgbClr val="C5CDD6"/>
+              </a:solidFill>
+            </c:spPr>
+          </c:dPt>
+          <c:dPt>
+            <c:idx val="2"/>
+            <c:spPr>
+              <a:solidFill>
+                <a:srgbClr val="C5CDD6"/>
+              </a:solidFill>
+            </c:spPr>
+          </c:dPt>
           <c:cat>
             <c:strRef>
               <c:f>Sheet1!$A$2:$A$4</c:f>
@@ -1054,7 +1066,7 @@
             </a:p>
           </c:txPr>
           <c:showLegendKey val="0"/>
-          <c:showVal val="0"/>
+          <c:showVal val="1"/>
           <c:showCatName val="0"/>
           <c:showSerName val="0"/>
           <c:showPercent val="0"/>
@@ -1229,7 +1241,7 @@
           <c:spPr>
             <a:ln>
               <a:solidFill>
-                <a:srgbClr val="F1F4F8"/>
+                <a:srgbClr val="DBE0E7"/>
               </a:solidFill>
             </a:ln>
           </c:spPr>
@@ -1589,7 +1601,7 @@
           <c:spPr>
             <a:ln>
               <a:solidFill>
-                <a:srgbClr val="F1F4F8"/>
+                <a:srgbClr val="DBE0E7"/>
               </a:solidFill>
             </a:ln>
           </c:spPr>
@@ -1666,6 +1678,70 @@
               <a:srgbClr val="1F3A5F"/>
             </a:solidFill>
           </c:spPr>
+          <c:dPt>
+            <c:idx val="0"/>
+            <c:spPr>
+              <a:solidFill>
+                <a:srgbClr val="E07A5F"/>
+              </a:solidFill>
+            </c:spPr>
+          </c:dPt>
+          <c:dPt>
+            <c:idx val="1"/>
+            <c:spPr>
+              <a:solidFill>
+                <a:srgbClr val="C5CDD6"/>
+              </a:solidFill>
+            </c:spPr>
+          </c:dPt>
+          <c:dPt>
+            <c:idx val="2"/>
+            <c:spPr>
+              <a:solidFill>
+                <a:srgbClr val="C5CDD6"/>
+              </a:solidFill>
+            </c:spPr>
+          </c:dPt>
+          <c:dPt>
+            <c:idx val="3"/>
+            <c:spPr>
+              <a:solidFill>
+                <a:srgbClr val="C5CDD6"/>
+              </a:solidFill>
+            </c:spPr>
+          </c:dPt>
+          <c:dPt>
+            <c:idx val="4"/>
+            <c:spPr>
+              <a:solidFill>
+                <a:srgbClr val="C5CDD6"/>
+              </a:solidFill>
+            </c:spPr>
+          </c:dPt>
+          <c:dPt>
+            <c:idx val="5"/>
+            <c:spPr>
+              <a:solidFill>
+                <a:srgbClr val="C5CDD6"/>
+              </a:solidFill>
+            </c:spPr>
+          </c:dPt>
+          <c:dPt>
+            <c:idx val="6"/>
+            <c:spPr>
+              <a:solidFill>
+                <a:srgbClr val="C5CDD6"/>
+              </a:solidFill>
+            </c:spPr>
+          </c:dPt>
+          <c:dPt>
+            <c:idx val="7"/>
+            <c:spPr>
+              <a:solidFill>
+                <a:srgbClr val="C5CDD6"/>
+              </a:solidFill>
+            </c:spPr>
+          </c:dPt>
           <c:cat>
             <c:strRef>
               <c:f>Sheet1!$A$2:$A$9</c:f>
@@ -1955,7 +2031,7 @@
           <c:spPr>
             <a:ln>
               <a:solidFill>
-                <a:srgbClr val="F1F4F8"/>
+                <a:srgbClr val="DBE0E7"/>
               </a:solidFill>
             </a:ln>
           </c:spPr>
@@ -5410,7 +5486,99 @@
       <p:grpSpPr/>
       <p:sp>
         <p:nvSpPr>
-          <p:cNvPr id="2" name="Rectangle 1"/>
+          <p:cNvPr id="2" name="Donut 1"/>
+          <p:cNvSpPr/>
+          <p:nvPr/>
+        </p:nvSpPr>
+        <p:spPr>
+          <a:xfrm>
+            <a:off x="8138160" y="822960"/>
+            <a:ext cx="6583680" cy="6583680"/>
+          </a:xfrm>
+          <a:prstGeom prst="donut">
+            <a:avLst>
+              <a:gd name="adj" fmla="val 16000"/>
+            </a:avLst>
+          </a:prstGeom>
+          <a:solidFill>
+            <a:srgbClr val="2F486A"/>
+          </a:solidFill>
+          <a:ln>
+            <a:noFill/>
+          </a:ln>
+          <a:effectLst/>
+        </p:spPr>
+        <p:style>
+          <a:lnRef idx="1">
+            <a:schemeClr val="accent1"/>
+          </a:lnRef>
+          <a:fillRef idx="3">
+            <a:schemeClr val="accent1"/>
+          </a:fillRef>
+          <a:effectRef idx="2">
+            <a:schemeClr val="accent1"/>
+          </a:effectRef>
+          <a:fontRef idx="minor">
+            <a:schemeClr val="lt1"/>
+          </a:fontRef>
+        </p:style>
+        <p:txBody>
+          <a:bodyPr rtlCol="0" anchor="ctr"/>
+          <a:lstStyle/>
+          <a:p>
+            <a:pPr algn="ctr"/>
+          </a:p>
+        </p:txBody>
+      </p:sp>
+      <p:sp>
+        <p:nvSpPr>
+          <p:cNvPr id="3" name="Donut 2"/>
+          <p:cNvSpPr/>
+          <p:nvPr/>
+        </p:nvSpPr>
+        <p:spPr>
+          <a:xfrm>
+            <a:off x="9692640" y="-1188720"/>
+            <a:ext cx="3657600" cy="3657600"/>
+          </a:xfrm>
+          <a:prstGeom prst="donut">
+            <a:avLst>
+              <a:gd name="adj" fmla="val 3500"/>
+            </a:avLst>
+          </a:prstGeom>
+          <a:solidFill>
+            <a:srgbClr val="E07A5F"/>
+          </a:solidFill>
+          <a:ln>
+            <a:noFill/>
+          </a:ln>
+          <a:effectLst/>
+        </p:spPr>
+        <p:style>
+          <a:lnRef idx="1">
+            <a:schemeClr val="accent1"/>
+          </a:lnRef>
+          <a:fillRef idx="3">
+            <a:schemeClr val="accent1"/>
+          </a:fillRef>
+          <a:effectRef idx="2">
+            <a:schemeClr val="accent1"/>
+          </a:effectRef>
+          <a:fontRef idx="minor">
+            <a:schemeClr val="lt1"/>
+          </a:fontRef>
+        </p:style>
+        <p:txBody>
+          <a:bodyPr rtlCol="0" anchor="ctr"/>
+          <a:lstStyle/>
+          <a:p>
+            <a:pPr algn="ctr"/>
+          </a:p>
+        </p:txBody>
+      </p:sp>
+      <p:sp>
+        <p:nvSpPr>
+          <p:cNvPr id="4" name="Rectangle 3"/>
           <p:cNvSpPr/>
           <p:nvPr/>
         </p:nvSpPr>
@@ -5428,6 +5596,7 @@
           <a:ln>
             <a:noFill/>
           </a:ln>
+          <a:effectLst/>
         </p:spPr>
         <p:style>
           <a:lnRef idx="1">
@@ -5453,14 +5622,14 @@
       </p:sp>
       <p:sp>
         <p:nvSpPr>
-          <p:cNvPr id="3" name="TextBox 2"/>
+          <p:cNvPr id="5" name="TextBox 4"/>
           <p:cNvSpPr txBox="1"/>
           <p:nvPr/>
         </p:nvSpPr>
         <p:spPr>
           <a:xfrm>
-            <a:off x="457200" y="1371600"/>
-            <a:ext cx="11277295" cy="1783080"/>
+            <a:off x="457200" y="731520"/>
+            <a:ext cx="7558851" cy="2423160"/>
           </a:xfrm>
           <a:prstGeom prst="rect">
             <a:avLst/>
@@ -5487,14 +5656,14 @@
       </p:sp>
       <p:sp>
         <p:nvSpPr>
-          <p:cNvPr id="4" name="TextBox 3"/>
+          <p:cNvPr id="6" name="TextBox 5"/>
           <p:cNvSpPr txBox="1"/>
           <p:nvPr/>
         </p:nvSpPr>
         <p:spPr>
           <a:xfrm>
             <a:off x="457200" y="3520440"/>
-            <a:ext cx="11277295" cy="1371600"/>
+            <a:ext cx="7558851" cy="1371600"/>
           </a:xfrm>
           <a:prstGeom prst="rect">
             <a:avLst/>
@@ -5507,14 +5676,59 @@
           </a:bodyPr>
           <a:lstStyle/>
           <a:p>
+            <a:pPr algn="l"/>
             <a:r>
               <a:rPr sz="2000">
                 <a:solidFill>
-                  <a:srgbClr val="D0D7E1"/>
+                  <a:srgbClr val="BCC4CF"/>
                 </a:solidFill>
                 <a:latin typeface="Calibri"/>
               </a:rPr>
               <a:t>Revenue, regions, channels and campaign performance</a:t>
+            </a:r>
+          </a:p>
+        </p:txBody>
+      </p:sp>
+      <p:sp>
+        <p:nvSpPr>
+          <p:cNvPr id="7" name="TextBox 6"/>
+          <p:cNvSpPr txBox="1"/>
+          <p:nvPr/>
+        </p:nvSpPr>
+        <p:spPr>
+          <a:xfrm>
+            <a:off x="457200" y="5943600"/>
+            <a:ext cx="5486400" cy="365760"/>
+          </a:xfrm>
+          <a:prstGeom prst="rect">
+            <a:avLst/>
+          </a:prstGeom>
+          <a:noFill/>
+        </p:spPr>
+        <p:txBody>
+          <a:bodyPr wrap="square" anchor="t" lIns="45720" rIns="45720">
+            <a:spAutoFit/>
+          </a:bodyPr>
+          <a:lstStyle/>
+          <a:p>
+            <a:pPr algn="l"/>
+            <a:r>
+              <a:rPr sz="1400" b="1">
+                <a:solidFill>
+                  <a:srgbClr val="E07A5F"/>
+                </a:solidFill>
+                <a:latin typeface="Calibri"/>
+              </a:rPr>
+              <a:t>Analytics Team</a:t>
+            </a:r>
+            <a:r>
+              <a:rPr sz="1400">
+                <a:solidFill>
+                  <a:srgbClr val="BCC4CF"/>
+                </a:solidFill>
+                <a:latin typeface="Calibri"/>
+              </a:rPr>
+              <a:t>   ·   SEPTEMBER 2026</a:t>
             </a:r>
           </a:p>
         </p:txBody>
@@ -5545,8 +5759,8 @@
         </p:nvSpPr>
         <p:spPr>
           <a:xfrm>
-            <a:off x="457200" y="320040"/>
-            <a:ext cx="11277295" cy="685800"/>
+            <a:off x="457200" y="182880"/>
+            <a:ext cx="11277295" cy="822960"/>
           </a:xfrm>
           <a:prstGeom prst="rect">
             <a:avLst/>
@@ -5615,7 +5829,7 @@
         <p:spPr>
           <a:xfrm>
             <a:off x="457200" y="6446520"/>
-            <a:ext cx="10362895" cy="274320"/>
+            <a:ext cx="6705295" cy="274320"/>
           </a:xfrm>
           <a:prstGeom prst="rect">
             <a:avLst/>
@@ -5676,9 +5890,97 @@
           </a:p>
         </p:txBody>
       </p:sp>
+      <p:sp>
+        <p:nvSpPr>
+          <p:cNvPr id="6" name="Rectangle 5"/>
+          <p:cNvSpPr/>
+          <p:nvPr/>
+        </p:nvSpPr>
+        <p:spPr>
+          <a:xfrm>
+            <a:off x="0" y="6803136"/>
+            <a:ext cx="12191695" cy="54864"/>
+          </a:xfrm>
+          <a:prstGeom prst="rect">
+            <a:avLst/>
+          </a:prstGeom>
+          <a:solidFill>
+            <a:srgbClr val="F1F4F8"/>
+          </a:solidFill>
+          <a:ln>
+            <a:noFill/>
+          </a:ln>
+          <a:effectLst/>
+        </p:spPr>
+        <p:style>
+          <a:lnRef idx="1">
+            <a:schemeClr val="accent1"/>
+          </a:lnRef>
+          <a:fillRef idx="3">
+            <a:schemeClr val="accent1"/>
+          </a:fillRef>
+          <a:effectRef idx="2">
+            <a:schemeClr val="accent1"/>
+          </a:effectRef>
+          <a:fontRef idx="minor">
+            <a:schemeClr val="lt1"/>
+          </a:fontRef>
+        </p:style>
+        <p:txBody>
+          <a:bodyPr rtlCol="0" anchor="ctr"/>
+          <a:lstStyle/>
+          <a:p>
+            <a:pPr algn="ctr"/>
+          </a:p>
+        </p:txBody>
+      </p:sp>
+      <p:sp>
+        <p:nvSpPr>
+          <p:cNvPr id="7" name="Rectangle 6"/>
+          <p:cNvSpPr/>
+          <p:nvPr/>
+        </p:nvSpPr>
+        <p:spPr>
+          <a:xfrm>
+            <a:off x="0" y="6803136"/>
+            <a:ext cx="2709265" cy="54864"/>
+          </a:xfrm>
+          <a:prstGeom prst="rect">
+            <a:avLst/>
+          </a:prstGeom>
+          <a:solidFill>
+            <a:srgbClr val="E07A5F"/>
+          </a:solidFill>
+          <a:ln>
+            <a:noFill/>
+          </a:ln>
+          <a:effectLst/>
+        </p:spPr>
+        <p:style>
+          <a:lnRef idx="1">
+            <a:schemeClr val="accent1"/>
+          </a:lnRef>
+          <a:fillRef idx="3">
+            <a:schemeClr val="accent1"/>
+          </a:fillRef>
+          <a:effectRef idx="2">
+            <a:schemeClr val="accent1"/>
+          </a:effectRef>
+          <a:fontRef idx="minor">
+            <a:schemeClr val="lt1"/>
+          </a:fontRef>
+        </p:style>
+        <p:txBody>
+          <a:bodyPr rtlCol="0" anchor="ctr"/>
+          <a:lstStyle/>
+          <a:p>
+            <a:pPr algn="ctr"/>
+          </a:p>
+        </p:txBody>
+      </p:sp>
       <p:graphicFrame>
         <p:nvGraphicFramePr>
-          <p:cNvPr id="6" name="Chart 5"/>
+          <p:cNvPr id="8" name="Chart 7"/>
           <p:cNvGraphicFramePr>
             <a:graphicFrameLocks noGrp="1"/>
           </p:cNvGraphicFramePr>
@@ -5696,7 +5998,7 @@
       </p:graphicFrame>
       <p:sp>
         <p:nvSpPr>
-          <p:cNvPr id="7" name="TextBox 6"/>
+          <p:cNvPr id="9" name="TextBox 8"/>
           <p:cNvSpPr txBox="1"/>
           <p:nvPr/>
         </p:nvSpPr>
@@ -5840,7 +6142,7 @@
       </p:sp>
       <p:sp>
         <p:nvSpPr>
-          <p:cNvPr id="8" name="Rounded Rectangle 7"/>
+          <p:cNvPr id="10" name="Rectangle 9"/>
           <p:cNvSpPr/>
           <p:nvPr/>
         </p:nvSpPr>
@@ -5849,10 +6151,8 @@
             <a:off x="457200" y="1417320"/>
             <a:ext cx="2647873" cy="1292961"/>
           </a:xfrm>
-          <a:prstGeom prst="roundRect">
-            <a:avLst>
-              <a:gd name="adj" fmla="val 8000"/>
-            </a:avLst>
+          <a:prstGeom prst="rect">
+            <a:avLst/>
           </a:prstGeom>
           <a:solidFill>
             <a:srgbClr val="F1F4F8"/>
@@ -5860,6 +6160,7 @@
           <a:ln>
             <a:noFill/>
           </a:ln>
+          <a:effectLst/>
         </p:spPr>
         <p:style>
           <a:lnRef idx="1">
@@ -5885,14 +6186,58 @@
       </p:sp>
       <p:sp>
         <p:nvSpPr>
-          <p:cNvPr id="9" name="TextBox 8"/>
+          <p:cNvPr id="11" name="Rectangle 10"/>
+          <p:cNvSpPr/>
+          <p:nvPr/>
+        </p:nvSpPr>
+        <p:spPr>
+          <a:xfrm>
+            <a:off x="457200" y="1417320"/>
+            <a:ext cx="73152" cy="1292961"/>
+          </a:xfrm>
+          <a:prstGeom prst="rect">
+            <a:avLst/>
+          </a:prstGeom>
+          <a:solidFill>
+            <a:srgbClr val="E07A5F"/>
+          </a:solidFill>
+          <a:ln>
+            <a:noFill/>
+          </a:ln>
+          <a:effectLst/>
+        </p:spPr>
+        <p:style>
+          <a:lnRef idx="1">
+            <a:schemeClr val="accent1"/>
+          </a:lnRef>
+          <a:fillRef idx="3">
+            <a:schemeClr val="accent1"/>
+          </a:fillRef>
+          <a:effectRef idx="2">
+            <a:schemeClr val="accent1"/>
+          </a:effectRef>
+          <a:fontRef idx="minor">
+            <a:schemeClr val="lt1"/>
+          </a:fontRef>
+        </p:style>
+        <p:txBody>
+          <a:bodyPr rtlCol="0" anchor="ctr"/>
+          <a:lstStyle/>
+          <a:p>
+            <a:pPr algn="ctr"/>
+          </a:p>
+        </p:txBody>
+      </p:sp>
+      <p:sp>
+        <p:nvSpPr>
+          <p:cNvPr id="12" name="TextBox 11"/>
           <p:cNvSpPr txBox="1"/>
           <p:nvPr/>
         </p:nvSpPr>
         <p:spPr>
           <a:xfrm>
-            <a:off x="640080" y="1508760"/>
-            <a:ext cx="2282113" cy="1110081"/>
+            <a:off x="731520" y="1508760"/>
+            <a:ext cx="2190673" cy="1110081"/>
           </a:xfrm>
           <a:prstGeom prst="rect">
             <a:avLst/>
@@ -5930,7 +6275,7 @@
       </p:sp>
       <p:sp>
         <p:nvSpPr>
-          <p:cNvPr id="10" name="Rounded Rectangle 9"/>
+          <p:cNvPr id="13" name="Rectangle 12"/>
           <p:cNvSpPr/>
           <p:nvPr/>
         </p:nvSpPr>
@@ -5939,10 +6284,8 @@
             <a:off x="3333673" y="1417320"/>
             <a:ext cx="2647873" cy="1292961"/>
           </a:xfrm>
-          <a:prstGeom prst="roundRect">
-            <a:avLst>
-              <a:gd name="adj" fmla="val 8000"/>
-            </a:avLst>
+          <a:prstGeom prst="rect">
+            <a:avLst/>
           </a:prstGeom>
           <a:solidFill>
             <a:srgbClr val="F1F4F8"/>
@@ -5950,6 +6293,7 @@
           <a:ln>
             <a:noFill/>
           </a:ln>
+          <a:effectLst/>
         </p:spPr>
         <p:style>
           <a:lnRef idx="1">
@@ -5975,14 +6319,58 @@
       </p:sp>
       <p:sp>
         <p:nvSpPr>
-          <p:cNvPr id="11" name="TextBox 10"/>
+          <p:cNvPr id="14" name="Rectangle 13"/>
+          <p:cNvSpPr/>
+          <p:nvPr/>
+        </p:nvSpPr>
+        <p:spPr>
+          <a:xfrm>
+            <a:off x="3333673" y="1417320"/>
+            <a:ext cx="73152" cy="1292961"/>
+          </a:xfrm>
+          <a:prstGeom prst="rect">
+            <a:avLst/>
+          </a:prstGeom>
+          <a:solidFill>
+            <a:srgbClr val="E07A5F"/>
+          </a:solidFill>
+          <a:ln>
+            <a:noFill/>
+          </a:ln>
+          <a:effectLst/>
+        </p:spPr>
+        <p:style>
+          <a:lnRef idx="1">
+            <a:schemeClr val="accent1"/>
+          </a:lnRef>
+          <a:fillRef idx="3">
+            <a:schemeClr val="accent1"/>
+          </a:fillRef>
+          <a:effectRef idx="2">
+            <a:schemeClr val="accent1"/>
+          </a:effectRef>
+          <a:fontRef idx="minor">
+            <a:schemeClr val="lt1"/>
+          </a:fontRef>
+        </p:style>
+        <p:txBody>
+          <a:bodyPr rtlCol="0" anchor="ctr"/>
+          <a:lstStyle/>
+          <a:p>
+            <a:pPr algn="ctr"/>
+          </a:p>
+        </p:txBody>
+      </p:sp>
+      <p:sp>
+        <p:nvSpPr>
+          <p:cNvPr id="15" name="TextBox 14"/>
           <p:cNvSpPr txBox="1"/>
           <p:nvPr/>
         </p:nvSpPr>
         <p:spPr>
           <a:xfrm>
-            <a:off x="3516553" y="1508760"/>
-            <a:ext cx="2282113" cy="1110081"/>
+            <a:off x="3607993" y="1508760"/>
+            <a:ext cx="2190673" cy="1110081"/>
           </a:xfrm>
           <a:prstGeom prst="rect">
             <a:avLst/>
@@ -6020,7 +6408,7 @@
       </p:sp>
       <p:sp>
         <p:nvSpPr>
-          <p:cNvPr id="12" name="Rounded Rectangle 11"/>
+          <p:cNvPr id="16" name="Rectangle 15"/>
           <p:cNvSpPr/>
           <p:nvPr/>
         </p:nvSpPr>
@@ -6029,10 +6417,8 @@
             <a:off x="6210147" y="1417320"/>
             <a:ext cx="2647873" cy="1292961"/>
           </a:xfrm>
-          <a:prstGeom prst="roundRect">
-            <a:avLst>
-              <a:gd name="adj" fmla="val 8000"/>
-            </a:avLst>
+          <a:prstGeom prst="rect">
+            <a:avLst/>
           </a:prstGeom>
           <a:solidFill>
             <a:srgbClr val="F1F4F8"/>
@@ -6040,6 +6426,7 @@
           <a:ln>
             <a:noFill/>
           </a:ln>
+          <a:effectLst/>
         </p:spPr>
         <p:style>
           <a:lnRef idx="1">
@@ -6065,14 +6452,58 @@
       </p:sp>
       <p:sp>
         <p:nvSpPr>
-          <p:cNvPr id="13" name="TextBox 12"/>
+          <p:cNvPr id="17" name="Rectangle 16"/>
+          <p:cNvSpPr/>
+          <p:nvPr/>
+        </p:nvSpPr>
+        <p:spPr>
+          <a:xfrm>
+            <a:off x="6210147" y="1417320"/>
+            <a:ext cx="73152" cy="1292961"/>
+          </a:xfrm>
+          <a:prstGeom prst="rect">
+            <a:avLst/>
+          </a:prstGeom>
+          <a:solidFill>
+            <a:srgbClr val="E07A5F"/>
+          </a:solidFill>
+          <a:ln>
+            <a:noFill/>
+          </a:ln>
+          <a:effectLst/>
+        </p:spPr>
+        <p:style>
+          <a:lnRef idx="1">
+            <a:schemeClr val="accent1"/>
+          </a:lnRef>
+          <a:fillRef idx="3">
+            <a:schemeClr val="accent1"/>
+          </a:fillRef>
+          <a:effectRef idx="2">
+            <a:schemeClr val="accent1"/>
+          </a:effectRef>
+          <a:fontRef idx="minor">
+            <a:schemeClr val="lt1"/>
+          </a:fontRef>
+        </p:style>
+        <p:txBody>
+          <a:bodyPr rtlCol="0" anchor="ctr"/>
+          <a:lstStyle/>
+          <a:p>
+            <a:pPr algn="ctr"/>
+          </a:p>
+        </p:txBody>
+      </p:sp>
+      <p:sp>
+        <p:nvSpPr>
+          <p:cNvPr id="18" name="TextBox 17"/>
           <p:cNvSpPr txBox="1"/>
           <p:nvPr/>
         </p:nvSpPr>
         <p:spPr>
           <a:xfrm>
-            <a:off x="6393027" y="1508760"/>
-            <a:ext cx="2282113" cy="1110081"/>
+            <a:off x="6484467" y="1508760"/>
+            <a:ext cx="2190673" cy="1110081"/>
           </a:xfrm>
           <a:prstGeom prst="rect">
             <a:avLst/>
@@ -6121,7 +6552,7 @@
       </p:sp>
       <p:sp>
         <p:nvSpPr>
-          <p:cNvPr id="14" name="Rounded Rectangle 13"/>
+          <p:cNvPr id="19" name="Rectangle 18"/>
           <p:cNvSpPr/>
           <p:nvPr/>
         </p:nvSpPr>
@@ -6130,10 +6561,8 @@
             <a:off x="9086621" y="1417320"/>
             <a:ext cx="2647873" cy="1292961"/>
           </a:xfrm>
-          <a:prstGeom prst="roundRect">
-            <a:avLst>
-              <a:gd name="adj" fmla="val 8000"/>
-            </a:avLst>
+          <a:prstGeom prst="rect">
+            <a:avLst/>
           </a:prstGeom>
           <a:solidFill>
             <a:srgbClr val="F1F4F8"/>
@@ -6141,6 +6570,7 @@
           <a:ln>
             <a:noFill/>
           </a:ln>
+          <a:effectLst/>
         </p:spPr>
         <p:style>
           <a:lnRef idx="1">
@@ -6166,14 +6596,58 @@
       </p:sp>
       <p:sp>
         <p:nvSpPr>
-          <p:cNvPr id="15" name="TextBox 14"/>
+          <p:cNvPr id="20" name="Rectangle 19"/>
+          <p:cNvSpPr/>
+          <p:nvPr/>
+        </p:nvSpPr>
+        <p:spPr>
+          <a:xfrm>
+            <a:off x="9086621" y="1417320"/>
+            <a:ext cx="73152" cy="1292961"/>
+          </a:xfrm>
+          <a:prstGeom prst="rect">
+            <a:avLst/>
+          </a:prstGeom>
+          <a:solidFill>
+            <a:srgbClr val="E07A5F"/>
+          </a:solidFill>
+          <a:ln>
+            <a:noFill/>
+          </a:ln>
+          <a:effectLst/>
+        </p:spPr>
+        <p:style>
+          <a:lnRef idx="1">
+            <a:schemeClr val="accent1"/>
+          </a:lnRef>
+          <a:fillRef idx="3">
+            <a:schemeClr val="accent1"/>
+          </a:fillRef>
+          <a:effectRef idx="2">
+            <a:schemeClr val="accent1"/>
+          </a:effectRef>
+          <a:fontRef idx="minor">
+            <a:schemeClr val="lt1"/>
+          </a:fontRef>
+        </p:style>
+        <p:txBody>
+          <a:bodyPr rtlCol="0" anchor="ctr"/>
+          <a:lstStyle/>
+          <a:p>
+            <a:pPr algn="ctr"/>
+          </a:p>
+        </p:txBody>
+      </p:sp>
+      <p:sp>
+        <p:nvSpPr>
+          <p:cNvPr id="21" name="TextBox 20"/>
           <p:cNvSpPr txBox="1"/>
           <p:nvPr/>
         </p:nvSpPr>
         <p:spPr>
           <a:xfrm>
-            <a:off x="9269501" y="1508760"/>
-            <a:ext cx="2282113" cy="1110081"/>
+            <a:off x="9360941" y="1508760"/>
+            <a:ext cx="2190673" cy="1110081"/>
           </a:xfrm>
           <a:prstGeom prst="rect">
             <a:avLst/>
@@ -6246,8 +6720,8 @@
         </p:nvSpPr>
         <p:spPr>
           <a:xfrm>
-            <a:off x="457200" y="320040"/>
-            <a:ext cx="11277295" cy="685800"/>
+            <a:off x="457200" y="182880"/>
+            <a:ext cx="11277295" cy="822960"/>
           </a:xfrm>
           <a:prstGeom prst="rect">
             <a:avLst/>
@@ -6281,7 +6755,7 @@
         <p:spPr>
           <a:xfrm>
             <a:off x="457200" y="6446520"/>
-            <a:ext cx="10362895" cy="274320"/>
+            <a:ext cx="6705295" cy="274320"/>
           </a:xfrm>
           <a:prstGeom prst="rect">
             <a:avLst/>
@@ -6344,7 +6818,95 @@
       </p:sp>
       <p:sp>
         <p:nvSpPr>
-          <p:cNvPr id="5" name="TextBox 4"/>
+          <p:cNvPr id="5" name="Rectangle 4"/>
+          <p:cNvSpPr/>
+          <p:nvPr/>
+        </p:nvSpPr>
+        <p:spPr>
+          <a:xfrm>
+            <a:off x="0" y="6803136"/>
+            <a:ext cx="12191695" cy="54864"/>
+          </a:xfrm>
+          <a:prstGeom prst="rect">
+            <a:avLst/>
+          </a:prstGeom>
+          <a:solidFill>
+            <a:srgbClr val="F1F4F8"/>
+          </a:solidFill>
+          <a:ln>
+            <a:noFill/>
+          </a:ln>
+          <a:effectLst/>
+        </p:spPr>
+        <p:style>
+          <a:lnRef idx="1">
+            <a:schemeClr val="accent1"/>
+          </a:lnRef>
+          <a:fillRef idx="3">
+            <a:schemeClr val="accent1"/>
+          </a:fillRef>
+          <a:effectRef idx="2">
+            <a:schemeClr val="accent1"/>
+          </a:effectRef>
+          <a:fontRef idx="minor">
+            <a:schemeClr val="lt1"/>
+          </a:fontRef>
+        </p:style>
+        <p:txBody>
+          <a:bodyPr rtlCol="0" anchor="ctr"/>
+          <a:lstStyle/>
+          <a:p>
+            <a:pPr algn="ctr"/>
+          </a:p>
+        </p:txBody>
+      </p:sp>
+      <p:sp>
+        <p:nvSpPr>
+          <p:cNvPr id="6" name="Rectangle 5"/>
+          <p:cNvSpPr/>
+          <p:nvPr/>
+        </p:nvSpPr>
+        <p:spPr>
+          <a:xfrm>
+            <a:off x="0" y="6803136"/>
+            <a:ext cx="4063898" cy="54864"/>
+          </a:xfrm>
+          <a:prstGeom prst="rect">
+            <a:avLst/>
+          </a:prstGeom>
+          <a:solidFill>
+            <a:srgbClr val="E07A5F"/>
+          </a:solidFill>
+          <a:ln>
+            <a:noFill/>
+          </a:ln>
+          <a:effectLst/>
+        </p:spPr>
+        <p:style>
+          <a:lnRef idx="1">
+            <a:schemeClr val="accent1"/>
+          </a:lnRef>
+          <a:fillRef idx="3">
+            <a:schemeClr val="accent1"/>
+          </a:fillRef>
+          <a:effectRef idx="2">
+            <a:schemeClr val="accent1"/>
+          </a:effectRef>
+          <a:fontRef idx="minor">
+            <a:schemeClr val="lt1"/>
+          </a:fontRef>
+        </p:style>
+        <p:txBody>
+          <a:bodyPr rtlCol="0" anchor="ctr"/>
+          <a:lstStyle/>
+          <a:p>
+            <a:pPr algn="ctr"/>
+          </a:p>
+        </p:txBody>
+      </p:sp>
+      <p:sp>
+        <p:nvSpPr>
+          <p:cNvPr id="7" name="TextBox 6"/>
           <p:cNvSpPr txBox="1"/>
           <p:nvPr/>
         </p:nvSpPr>
@@ -6463,7 +7025,7 @@
       </p:sp>
       <p:graphicFrame>
         <p:nvGraphicFramePr>
-          <p:cNvPr id="6" name="Chart 5"/>
+          <p:cNvPr id="8" name="Chart 7"/>
           <p:cNvGraphicFramePr>
             <a:graphicFrameLocks noGrp="1"/>
           </p:cNvGraphicFramePr>
@@ -6505,8 +7067,8 @@
         </p:nvSpPr>
         <p:spPr>
           <a:xfrm>
-            <a:off x="457200" y="320040"/>
-            <a:ext cx="11277295" cy="685800"/>
+            <a:off x="457200" y="182880"/>
+            <a:ext cx="11277295" cy="822960"/>
           </a:xfrm>
           <a:prstGeom prst="rect">
             <a:avLst/>
@@ -6540,7 +7102,7 @@
         <p:spPr>
           <a:xfrm>
             <a:off x="457200" y="6446520"/>
-            <a:ext cx="10362895" cy="274320"/>
+            <a:ext cx="6705295" cy="274320"/>
           </a:xfrm>
           <a:prstGeom prst="rect">
             <a:avLst/>
@@ -6601,70 +7163,16 @@
           </a:p>
         </p:txBody>
       </p:sp>
-      <p:graphicFrame>
-        <p:nvGraphicFramePr>
-          <p:cNvPr id="5" name="Chart 4"/>
-          <p:cNvGraphicFramePr>
-            <a:graphicFrameLocks noGrp="1"/>
-          </p:cNvGraphicFramePr>
-          <p:nvPr/>
-        </p:nvGraphicFramePr>
-        <p:xfrm>
-          <a:off x="457200" y="1417320"/>
-          <a:ext cx="3576218" cy="3601821"/>
-        </p:xfrm>
-        <a:graphic>
-          <a:graphicData uri="http://schemas.openxmlformats.org/drawingml/2006/chart">
-            <c:chart xmlns:c="http://schemas.openxmlformats.org/drawingml/2006/chart" r:id="rId2"/>
-          </a:graphicData>
-        </a:graphic>
-      </p:graphicFrame>
-      <p:graphicFrame>
-        <p:nvGraphicFramePr>
-          <p:cNvPr id="6" name="Chart 5"/>
-          <p:cNvGraphicFramePr>
-            <a:graphicFrameLocks noGrp="1"/>
-          </p:cNvGraphicFramePr>
-          <p:nvPr/>
-        </p:nvGraphicFramePr>
-        <p:xfrm>
-          <a:off x="4307738" y="1417320"/>
-          <a:ext cx="3576218" cy="3601821"/>
-        </p:xfrm>
-        <a:graphic>
-          <a:graphicData uri="http://schemas.openxmlformats.org/drawingml/2006/chart">
-            <c:chart xmlns:c="http://schemas.openxmlformats.org/drawingml/2006/chart" r:id="rId3"/>
-          </a:graphicData>
-        </a:graphic>
-      </p:graphicFrame>
-      <p:graphicFrame>
-        <p:nvGraphicFramePr>
-          <p:cNvPr id="7" name="Chart 6"/>
-          <p:cNvGraphicFramePr>
-            <a:graphicFrameLocks noGrp="1"/>
-          </p:cNvGraphicFramePr>
-          <p:nvPr/>
-        </p:nvGraphicFramePr>
-        <p:xfrm>
-          <a:off x="8158276" y="1417320"/>
-          <a:ext cx="3576218" cy="3601821"/>
-        </p:xfrm>
-        <a:graphic>
-          <a:graphicData uri="http://schemas.openxmlformats.org/drawingml/2006/chart">
-            <c:chart xmlns:c="http://schemas.openxmlformats.org/drawingml/2006/chart" r:id="rId4"/>
-          </a:graphicData>
-        </a:graphic>
-      </p:graphicFrame>
-      <p:sp>
-        <p:nvSpPr>
-          <p:cNvPr id="8" name="Rectangle 7"/>
+      <p:sp>
+        <p:nvSpPr>
+          <p:cNvPr id="5" name="Rectangle 4"/>
           <p:cNvSpPr/>
           <p:nvPr/>
         </p:nvSpPr>
         <p:spPr>
           <a:xfrm>
-            <a:off x="457200" y="5293461"/>
-            <a:ext cx="11277295" cy="1015898"/>
+            <a:off x="0" y="6803136"/>
+            <a:ext cx="12191695" cy="54864"/>
           </a:xfrm>
           <a:prstGeom prst="rect">
             <a:avLst/>
@@ -6675,6 +7183,7 @@
           <a:ln>
             <a:noFill/>
           </a:ln>
+          <a:effectLst/>
         </p:spPr>
         <p:style>
           <a:lnRef idx="1">
@@ -6700,14 +7209,14 @@
       </p:sp>
       <p:sp>
         <p:nvSpPr>
-          <p:cNvPr id="9" name="Rectangle 8"/>
+          <p:cNvPr id="6" name="Rectangle 5"/>
           <p:cNvSpPr/>
           <p:nvPr/>
         </p:nvSpPr>
         <p:spPr>
           <a:xfrm>
-            <a:off x="457200" y="5293461"/>
-            <a:ext cx="73152" cy="1015898"/>
+            <a:off x="0" y="6803136"/>
+            <a:ext cx="5418531" cy="54864"/>
           </a:xfrm>
           <a:prstGeom prst="rect">
             <a:avLst/>
@@ -6718,6 +7227,7 @@
           <a:ln>
             <a:noFill/>
           </a:ln>
+          <a:effectLst/>
         </p:spPr>
         <p:style>
           <a:lnRef idx="1">
@@ -6743,7 +7253,287 @@
       </p:sp>
       <p:sp>
         <p:nvSpPr>
-          <p:cNvPr id="10" name="TextBox 9"/>
+          <p:cNvPr id="7" name="Rounded Rectangle 6"/>
+          <p:cNvSpPr/>
+          <p:nvPr/>
+        </p:nvSpPr>
+        <p:spPr>
+          <a:xfrm>
+            <a:off x="457200" y="1417320"/>
+            <a:ext cx="3576218" cy="3601821"/>
+          </a:xfrm>
+          <a:prstGeom prst="roundRect">
+            <a:avLst>
+              <a:gd name="adj" fmla="val 3068"/>
+            </a:avLst>
+          </a:prstGeom>
+          <a:solidFill>
+            <a:srgbClr val="F1F4F8"/>
+          </a:solidFill>
+          <a:ln>
+            <a:noFill/>
+          </a:ln>
+          <a:effectLst/>
+        </p:spPr>
+        <p:style>
+          <a:lnRef idx="1">
+            <a:schemeClr val="accent1"/>
+          </a:lnRef>
+          <a:fillRef idx="3">
+            <a:schemeClr val="accent1"/>
+          </a:fillRef>
+          <a:effectRef idx="2">
+            <a:schemeClr val="accent1"/>
+          </a:effectRef>
+          <a:fontRef idx="minor">
+            <a:schemeClr val="lt1"/>
+          </a:fontRef>
+        </p:style>
+        <p:txBody>
+          <a:bodyPr rtlCol="0" anchor="ctr"/>
+          <a:lstStyle/>
+          <a:p>
+            <a:pPr algn="ctr"/>
+          </a:p>
+        </p:txBody>
+      </p:sp>
+      <p:graphicFrame>
+        <p:nvGraphicFramePr>
+          <p:cNvPr id="8" name="Chart 7"/>
+          <p:cNvGraphicFramePr>
+            <a:graphicFrameLocks noGrp="1"/>
+          </p:cNvGraphicFramePr>
+          <p:nvPr/>
+        </p:nvGraphicFramePr>
+        <p:xfrm>
+          <a:off x="640080" y="1600200"/>
+          <a:ext cx="3210458" cy="3236061"/>
+        </p:xfrm>
+        <a:graphic>
+          <a:graphicData uri="http://schemas.openxmlformats.org/drawingml/2006/chart">
+            <c:chart xmlns:c="http://schemas.openxmlformats.org/drawingml/2006/chart" r:id="rId2"/>
+          </a:graphicData>
+        </a:graphic>
+      </p:graphicFrame>
+      <p:sp>
+        <p:nvSpPr>
+          <p:cNvPr id="9" name="Rounded Rectangle 8"/>
+          <p:cNvSpPr/>
+          <p:nvPr/>
+        </p:nvSpPr>
+        <p:spPr>
+          <a:xfrm>
+            <a:off x="4307738" y="1417320"/>
+            <a:ext cx="3576218" cy="3601821"/>
+          </a:xfrm>
+          <a:prstGeom prst="roundRect">
+            <a:avLst>
+              <a:gd name="adj" fmla="val 3068"/>
+            </a:avLst>
+          </a:prstGeom>
+          <a:solidFill>
+            <a:srgbClr val="F1F4F8"/>
+          </a:solidFill>
+          <a:ln>
+            <a:noFill/>
+          </a:ln>
+          <a:effectLst/>
+        </p:spPr>
+        <p:style>
+          <a:lnRef idx="1">
+            <a:schemeClr val="accent1"/>
+          </a:lnRef>
+          <a:fillRef idx="3">
+            <a:schemeClr val="accent1"/>
+          </a:fillRef>
+          <a:effectRef idx="2">
+            <a:schemeClr val="accent1"/>
+          </a:effectRef>
+          <a:fontRef idx="minor">
+            <a:schemeClr val="lt1"/>
+          </a:fontRef>
+        </p:style>
+        <p:txBody>
+          <a:bodyPr rtlCol="0" anchor="ctr"/>
+          <a:lstStyle/>
+          <a:p>
+            <a:pPr algn="ctr"/>
+          </a:p>
+        </p:txBody>
+      </p:sp>
+      <p:graphicFrame>
+        <p:nvGraphicFramePr>
+          <p:cNvPr id="10" name="Chart 9"/>
+          <p:cNvGraphicFramePr>
+            <a:graphicFrameLocks noGrp="1"/>
+          </p:cNvGraphicFramePr>
+          <p:nvPr/>
+        </p:nvGraphicFramePr>
+        <p:xfrm>
+          <a:off x="4490618" y="1600200"/>
+          <a:ext cx="3210458" cy="3236061"/>
+        </p:xfrm>
+        <a:graphic>
+          <a:graphicData uri="http://schemas.openxmlformats.org/drawingml/2006/chart">
+            <c:chart xmlns:c="http://schemas.openxmlformats.org/drawingml/2006/chart" r:id="rId3"/>
+          </a:graphicData>
+        </a:graphic>
+      </p:graphicFrame>
+      <p:sp>
+        <p:nvSpPr>
+          <p:cNvPr id="11" name="Rounded Rectangle 10"/>
+          <p:cNvSpPr/>
+          <p:nvPr/>
+        </p:nvSpPr>
+        <p:spPr>
+          <a:xfrm>
+            <a:off x="8158276" y="1417320"/>
+            <a:ext cx="3576218" cy="3601821"/>
+          </a:xfrm>
+          <a:prstGeom prst="roundRect">
+            <a:avLst>
+              <a:gd name="adj" fmla="val 3068"/>
+            </a:avLst>
+          </a:prstGeom>
+          <a:solidFill>
+            <a:srgbClr val="F1F4F8"/>
+          </a:solidFill>
+          <a:ln>
+            <a:noFill/>
+          </a:ln>
+          <a:effectLst/>
+        </p:spPr>
+        <p:style>
+          <a:lnRef idx="1">
+            <a:schemeClr val="accent1"/>
+          </a:lnRef>
+          <a:fillRef idx="3">
+            <a:schemeClr val="accent1"/>
+          </a:fillRef>
+          <a:effectRef idx="2">
+            <a:schemeClr val="accent1"/>
+          </a:effectRef>
+          <a:fontRef idx="minor">
+            <a:schemeClr val="lt1"/>
+          </a:fontRef>
+        </p:style>
+        <p:txBody>
+          <a:bodyPr rtlCol="0" anchor="ctr"/>
+          <a:lstStyle/>
+          <a:p>
+            <a:pPr algn="ctr"/>
+          </a:p>
+        </p:txBody>
+      </p:sp>
+      <p:graphicFrame>
+        <p:nvGraphicFramePr>
+          <p:cNvPr id="12" name="Chart 11"/>
+          <p:cNvGraphicFramePr>
+            <a:graphicFrameLocks noGrp="1"/>
+          </p:cNvGraphicFramePr>
+          <p:nvPr/>
+        </p:nvGraphicFramePr>
+        <p:xfrm>
+          <a:off x="8341156" y="1600200"/>
+          <a:ext cx="3210458" cy="3236061"/>
+        </p:xfrm>
+        <a:graphic>
+          <a:graphicData uri="http://schemas.openxmlformats.org/drawingml/2006/chart">
+            <c:chart xmlns:c="http://schemas.openxmlformats.org/drawingml/2006/chart" r:id="rId4"/>
+          </a:graphicData>
+        </a:graphic>
+      </p:graphicFrame>
+      <p:sp>
+        <p:nvSpPr>
+          <p:cNvPr id="13" name="Rectangle 12"/>
+          <p:cNvSpPr/>
+          <p:nvPr/>
+        </p:nvSpPr>
+        <p:spPr>
+          <a:xfrm>
+            <a:off x="457200" y="5293461"/>
+            <a:ext cx="11277295" cy="1015898"/>
+          </a:xfrm>
+          <a:prstGeom prst="rect">
+            <a:avLst/>
+          </a:prstGeom>
+          <a:solidFill>
+            <a:srgbClr val="F1F4F8"/>
+          </a:solidFill>
+          <a:ln>
+            <a:noFill/>
+          </a:ln>
+          <a:effectLst/>
+        </p:spPr>
+        <p:style>
+          <a:lnRef idx="1">
+            <a:schemeClr val="accent1"/>
+          </a:lnRef>
+          <a:fillRef idx="3">
+            <a:schemeClr val="accent1"/>
+          </a:fillRef>
+          <a:effectRef idx="2">
+            <a:schemeClr val="accent1"/>
+          </a:effectRef>
+          <a:fontRef idx="minor">
+            <a:schemeClr val="lt1"/>
+          </a:fontRef>
+        </p:style>
+        <p:txBody>
+          <a:bodyPr rtlCol="0" anchor="ctr"/>
+          <a:lstStyle/>
+          <a:p>
+            <a:pPr algn="ctr"/>
+          </a:p>
+        </p:txBody>
+      </p:sp>
+      <p:sp>
+        <p:nvSpPr>
+          <p:cNvPr id="14" name="Rectangle 13"/>
+          <p:cNvSpPr/>
+          <p:nvPr/>
+        </p:nvSpPr>
+        <p:spPr>
+          <a:xfrm>
+            <a:off x="457200" y="5293461"/>
+            <a:ext cx="73152" cy="1015898"/>
+          </a:xfrm>
+          <a:prstGeom prst="rect">
+            <a:avLst/>
+          </a:prstGeom>
+          <a:solidFill>
+            <a:srgbClr val="E07A5F"/>
+          </a:solidFill>
+          <a:ln>
+            <a:noFill/>
+          </a:ln>
+          <a:effectLst/>
+        </p:spPr>
+        <p:style>
+          <a:lnRef idx="1">
+            <a:schemeClr val="accent1"/>
+          </a:lnRef>
+          <a:fillRef idx="3">
+            <a:schemeClr val="accent1"/>
+          </a:fillRef>
+          <a:effectRef idx="2">
+            <a:schemeClr val="accent1"/>
+          </a:effectRef>
+          <a:fontRef idx="minor">
+            <a:schemeClr val="lt1"/>
+          </a:fontRef>
+        </p:style>
+        <p:txBody>
+          <a:bodyPr rtlCol="0" anchor="ctr"/>
+          <a:lstStyle/>
+          <a:p>
+            <a:pPr algn="ctr"/>
+          </a:p>
+        </p:txBody>
+      </p:sp>
+      <p:sp>
+        <p:nvSpPr>
+          <p:cNvPr id="15" name="TextBox 14"/>
           <p:cNvSpPr txBox="1"/>
           <p:nvPr/>
         </p:nvSpPr>
@@ -6821,7 +7611,42 @@
       <p:grpSpPr/>
       <p:sp>
         <p:nvSpPr>
-          <p:cNvPr id="2" name="Rectangle 1"/>
+          <p:cNvPr id="2" name="TextBox 1"/>
+          <p:cNvSpPr txBox="1"/>
+          <p:nvPr/>
+        </p:nvSpPr>
+        <p:spPr>
+          <a:xfrm>
+            <a:off x="6095847" y="182880"/>
+            <a:ext cx="5821527" cy="6492240"/>
+          </a:xfrm>
+          <a:prstGeom prst="rect">
+            <a:avLst/>
+          </a:prstGeom>
+          <a:noFill/>
+        </p:spPr>
+        <p:txBody>
+          <a:bodyPr wrap="square" anchor="ctr" lIns="45720" rIns="45720">
+            <a:spAutoFit/>
+          </a:bodyPr>
+          <a:lstStyle/>
+          <a:p>
+            <a:pPr algn="r"/>
+            <a:r>
+              <a:rPr sz="30000" b="1">
+                <a:solidFill>
+                  <a:srgbClr val="E2E7ED"/>
+                </a:solidFill>
+                <a:latin typeface="Calibri"/>
+              </a:rPr>
+              <a:t>02</a:t>
+            </a:r>
+          </a:p>
+        </p:txBody>
+      </p:sp>
+      <p:sp>
+        <p:nvSpPr>
+          <p:cNvPr id="3" name="Rectangle 2"/>
           <p:cNvSpPr/>
           <p:nvPr/>
         </p:nvSpPr>
@@ -6839,6 +7664,7 @@
           <a:ln>
             <a:noFill/>
           </a:ln>
+          <a:effectLst/>
         </p:spPr>
         <p:style>
           <a:lnRef idx="1">
@@ -6864,14 +7690,14 @@
       </p:sp>
       <p:sp>
         <p:nvSpPr>
-          <p:cNvPr id="3" name="TextBox 2"/>
+          <p:cNvPr id="4" name="TextBox 3"/>
           <p:cNvSpPr txBox="1"/>
           <p:nvPr/>
         </p:nvSpPr>
         <p:spPr>
           <a:xfrm>
-            <a:off x="457200" y="1371600"/>
-            <a:ext cx="11277295" cy="1783080"/>
+            <a:off x="457200" y="731520"/>
+            <a:ext cx="7558851" cy="2423160"/>
           </a:xfrm>
           <a:prstGeom prst="rect">
             <a:avLst/>
@@ -6884,6 +7710,22 @@
           </a:bodyPr>
           <a:lstStyle/>
           <a:p>
+            <a:pPr>
+              <a:spcAft>
+                <a:spcPts val="600"/>
+              </a:spcAft>
+            </a:pPr>
+            <a:r>
+              <a:rPr sz="1600" b="1">
+                <a:solidFill>
+                  <a:srgbClr val="E07A5F"/>
+                </a:solidFill>
+                <a:latin typeface="Calibri"/>
+              </a:rPr>
+              <a:t>PART TWO</a:t>
+            </a:r>
+          </a:p>
+          <a:p>
             <a:r>
               <a:rPr sz="4000" b="1">
                 <a:solidFill>
@@ -6898,14 +7740,14 @@
       </p:sp>
       <p:sp>
         <p:nvSpPr>
-          <p:cNvPr id="4" name="TextBox 3"/>
+          <p:cNvPr id="5" name="TextBox 4"/>
           <p:cNvSpPr txBox="1"/>
           <p:nvPr/>
         </p:nvSpPr>
         <p:spPr>
           <a:xfrm>
             <a:off x="457200" y="3520440"/>
-            <a:ext cx="11277295" cy="1371600"/>
+            <a:ext cx="7558851" cy="1371600"/>
           </a:xfrm>
           <a:prstGeom prst="rect">
             <a:avLst/>
@@ -6918,6 +7760,7 @@
           </a:bodyPr>
           <a:lstStyle/>
           <a:p>
+            <a:pPr algn="l"/>
             <a:r>
               <a:rPr sz="2000">
                 <a:solidFill>
@@ -6956,8 +7799,8 @@
         </p:nvSpPr>
         <p:spPr>
           <a:xfrm>
-            <a:off x="457200" y="320040"/>
-            <a:ext cx="11277295" cy="685800"/>
+            <a:off x="457200" y="182880"/>
+            <a:ext cx="11277295" cy="822960"/>
           </a:xfrm>
           <a:prstGeom prst="rect">
             <a:avLst/>
@@ -6991,7 +7834,7 @@
         <p:spPr>
           <a:xfrm>
             <a:off x="457200" y="6446520"/>
-            <a:ext cx="10362895" cy="274320"/>
+            <a:ext cx="6705295" cy="274320"/>
           </a:xfrm>
           <a:prstGeom prst="rect">
             <a:avLst/>
@@ -7052,9 +7895,132 @@
           </a:p>
         </p:txBody>
       </p:sp>
+      <p:sp>
+        <p:nvSpPr>
+          <p:cNvPr id="5" name="TextBox 4"/>
+          <p:cNvSpPr txBox="1"/>
+          <p:nvPr/>
+        </p:nvSpPr>
+        <p:spPr>
+          <a:xfrm>
+            <a:off x="7436815" y="6446520"/>
+            <a:ext cx="3657600" cy="274320"/>
+          </a:xfrm>
+          <a:prstGeom prst="rect">
+            <a:avLst/>
+          </a:prstGeom>
+          <a:noFill/>
+        </p:spPr>
+        <p:txBody>
+          <a:bodyPr wrap="square" anchor="t" lIns="45720" rIns="45720">
+            <a:spAutoFit/>
+          </a:bodyPr>
+          <a:lstStyle/>
+          <a:p>
+            <a:pPr algn="r"/>
+            <a:r>
+              <a:rPr sz="1000" b="1">
+                <a:solidFill>
+                  <a:srgbClr val="E07A5F"/>
+                </a:solidFill>
+                <a:latin typeface="Calibri"/>
+              </a:rPr>
+              <a:t>Campaign performance</a:t>
+            </a:r>
+          </a:p>
+        </p:txBody>
+      </p:sp>
+      <p:sp>
+        <p:nvSpPr>
+          <p:cNvPr id="6" name="Rectangle 5"/>
+          <p:cNvSpPr/>
+          <p:nvPr/>
+        </p:nvSpPr>
+        <p:spPr>
+          <a:xfrm>
+            <a:off x="0" y="6803136"/>
+            <a:ext cx="12191695" cy="54864"/>
+          </a:xfrm>
+          <a:prstGeom prst="rect">
+            <a:avLst/>
+          </a:prstGeom>
+          <a:solidFill>
+            <a:srgbClr val="F1F4F8"/>
+          </a:solidFill>
+          <a:ln>
+            <a:noFill/>
+          </a:ln>
+          <a:effectLst/>
+        </p:spPr>
+        <p:style>
+          <a:lnRef idx="1">
+            <a:schemeClr val="accent1"/>
+          </a:lnRef>
+          <a:fillRef idx="3">
+            <a:schemeClr val="accent1"/>
+          </a:fillRef>
+          <a:effectRef idx="2">
+            <a:schemeClr val="accent1"/>
+          </a:effectRef>
+          <a:fontRef idx="minor">
+            <a:schemeClr val="lt1"/>
+          </a:fontRef>
+        </p:style>
+        <p:txBody>
+          <a:bodyPr rtlCol="0" anchor="ctr"/>
+          <a:lstStyle/>
+          <a:p>
+            <a:pPr algn="ctr"/>
+          </a:p>
+        </p:txBody>
+      </p:sp>
+      <p:sp>
+        <p:nvSpPr>
+          <p:cNvPr id="7" name="Rectangle 6"/>
+          <p:cNvSpPr/>
+          <p:nvPr/>
+        </p:nvSpPr>
+        <p:spPr>
+          <a:xfrm>
+            <a:off x="0" y="6803136"/>
+            <a:ext cx="8127796" cy="54864"/>
+          </a:xfrm>
+          <a:prstGeom prst="rect">
+            <a:avLst/>
+          </a:prstGeom>
+          <a:solidFill>
+            <a:srgbClr val="E07A5F"/>
+          </a:solidFill>
+          <a:ln>
+            <a:noFill/>
+          </a:ln>
+          <a:effectLst/>
+        </p:spPr>
+        <p:style>
+          <a:lnRef idx="1">
+            <a:schemeClr val="accent1"/>
+          </a:lnRef>
+          <a:fillRef idx="3">
+            <a:schemeClr val="accent1"/>
+          </a:fillRef>
+          <a:effectRef idx="2">
+            <a:schemeClr val="accent1"/>
+          </a:effectRef>
+          <a:fontRef idx="minor">
+            <a:schemeClr val="lt1"/>
+          </a:fontRef>
+        </p:style>
+        <p:txBody>
+          <a:bodyPr rtlCol="0" anchor="ctr"/>
+          <a:lstStyle/>
+          <a:p>
+            <a:pPr algn="ctr"/>
+          </a:p>
+        </p:txBody>
+      </p:sp>
       <p:graphicFrame>
         <p:nvGraphicFramePr>
-          <p:cNvPr id="5" name="Chart 4"/>
+          <p:cNvPr id="8" name="Chart 7"/>
           <p:cNvGraphicFramePr>
             <a:graphicFrameLocks noGrp="1"/>
           </p:cNvGraphicFramePr>
@@ -7072,7 +8038,7 @@
       </p:graphicFrame>
       <p:graphicFrame>
         <p:nvGraphicFramePr>
-          <p:cNvPr id="6" name="Table 5"/>
+          <p:cNvPr id="9" name="Table 8"/>
           <p:cNvGraphicFramePr>
             <a:graphicFrameLocks noGrp="1"/>
           </p:cNvGraphicFramePr>
@@ -7104,7 +8070,7 @@
                       <a:r>
                         <a:rPr sz="1200" b="1">
                           <a:solidFill>
-                            <a:srgbClr val="F1F4F8"/>
+                            <a:srgbClr val="FFFFFF"/>
                           </a:solidFill>
                           <a:latin typeface="Calibri"/>
                         </a:rPr>
@@ -7127,7 +8093,7 @@
                       <a:r>
                         <a:rPr sz="1200" b="1">
                           <a:solidFill>
-                            <a:srgbClr val="F1F4F8"/>
+                            <a:srgbClr val="FFFFFF"/>
                           </a:solidFill>
                           <a:latin typeface="Calibri"/>
                         </a:rPr>
@@ -7150,7 +8116,7 @@
                       <a:r>
                         <a:rPr sz="1200" b="1">
                           <a:solidFill>
-                            <a:srgbClr val="F1F4F8"/>
+                            <a:srgbClr val="FFFFFF"/>
                           </a:solidFill>
                           <a:latin typeface="Calibri"/>
                         </a:rPr>
@@ -7173,7 +8139,7 @@
                       <a:r>
                         <a:rPr sz="1200" b="1">
                           <a:solidFill>
-                            <a:srgbClr val="F1F4F8"/>
+                            <a:srgbClr val="FFFFFF"/>
                           </a:solidFill>
                           <a:latin typeface="Calibri"/>
                         </a:rPr>
@@ -7782,8 +8748,8 @@
         </p:nvSpPr>
         <p:spPr>
           <a:xfrm>
-            <a:off x="457200" y="320040"/>
-            <a:ext cx="11277295" cy="685800"/>
+            <a:off x="457200" y="182880"/>
+            <a:ext cx="11277295" cy="822960"/>
           </a:xfrm>
           <a:prstGeom prst="rect">
             <a:avLst/>
@@ -7880,18 +8846,141 @@
       </p:sp>
       <p:sp>
         <p:nvSpPr>
-          <p:cNvPr id="5" name="Rounded Rectangle 4"/>
+          <p:cNvPr id="5" name="TextBox 4"/>
+          <p:cNvSpPr txBox="1"/>
+          <p:nvPr/>
+        </p:nvSpPr>
+        <p:spPr>
+          <a:xfrm>
+            <a:off x="7436815" y="6446520"/>
+            <a:ext cx="3657600" cy="274320"/>
+          </a:xfrm>
+          <a:prstGeom prst="rect">
+            <a:avLst/>
+          </a:prstGeom>
+          <a:noFill/>
+        </p:spPr>
+        <p:txBody>
+          <a:bodyPr wrap="square" anchor="t" lIns="45720" rIns="45720">
+            <a:spAutoFit/>
+          </a:bodyPr>
+          <a:lstStyle/>
+          <a:p>
+            <a:pPr algn="r"/>
+            <a:r>
+              <a:rPr sz="1000" b="1">
+                <a:solidFill>
+                  <a:srgbClr val="E07A5F"/>
+                </a:solidFill>
+                <a:latin typeface="Calibri"/>
+              </a:rPr>
+              <a:t>Campaign performance</a:t>
+            </a:r>
+          </a:p>
+        </p:txBody>
+      </p:sp>
+      <p:sp>
+        <p:nvSpPr>
+          <p:cNvPr id="6" name="Rectangle 5"/>
           <p:cNvSpPr/>
           <p:nvPr/>
         </p:nvSpPr>
         <p:spPr>
           <a:xfrm>
+            <a:off x="0" y="6803136"/>
+            <a:ext cx="12191695" cy="54864"/>
+          </a:xfrm>
+          <a:prstGeom prst="rect">
+            <a:avLst/>
+          </a:prstGeom>
+          <a:solidFill>
+            <a:srgbClr val="F1F4F8"/>
+          </a:solidFill>
+          <a:ln>
+            <a:noFill/>
+          </a:ln>
+          <a:effectLst/>
+        </p:spPr>
+        <p:style>
+          <a:lnRef idx="1">
+            <a:schemeClr val="accent1"/>
+          </a:lnRef>
+          <a:fillRef idx="3">
+            <a:schemeClr val="accent1"/>
+          </a:fillRef>
+          <a:effectRef idx="2">
+            <a:schemeClr val="accent1"/>
+          </a:effectRef>
+          <a:fontRef idx="minor">
+            <a:schemeClr val="lt1"/>
+          </a:fontRef>
+        </p:style>
+        <p:txBody>
+          <a:bodyPr rtlCol="0" anchor="ctr"/>
+          <a:lstStyle/>
+          <a:p>
+            <a:pPr algn="ctr"/>
+          </a:p>
+        </p:txBody>
+      </p:sp>
+      <p:sp>
+        <p:nvSpPr>
+          <p:cNvPr id="7" name="Rectangle 6"/>
+          <p:cNvSpPr/>
+          <p:nvPr/>
+        </p:nvSpPr>
+        <p:spPr>
+          <a:xfrm>
+            <a:off x="0" y="6803136"/>
+            <a:ext cx="9482429" cy="54864"/>
+          </a:xfrm>
+          <a:prstGeom prst="rect">
+            <a:avLst/>
+          </a:prstGeom>
+          <a:solidFill>
+            <a:srgbClr val="E07A5F"/>
+          </a:solidFill>
+          <a:ln>
+            <a:noFill/>
+          </a:ln>
+          <a:effectLst/>
+        </p:spPr>
+        <p:style>
+          <a:lnRef idx="1">
+            <a:schemeClr val="accent1"/>
+          </a:lnRef>
+          <a:fillRef idx="3">
+            <a:schemeClr val="accent1"/>
+          </a:fillRef>
+          <a:effectRef idx="2">
+            <a:schemeClr val="accent1"/>
+          </a:effectRef>
+          <a:fontRef idx="minor">
+            <a:schemeClr val="lt1"/>
+          </a:fontRef>
+        </p:style>
+        <p:txBody>
+          <a:bodyPr rtlCol="0" anchor="ctr"/>
+          <a:lstStyle/>
+          <a:p>
+            <a:pPr algn="ctr"/>
+          </a:p>
+        </p:txBody>
+      </p:sp>
+      <p:sp>
+        <p:nvSpPr>
+          <p:cNvPr id="8" name="Rounded Rectangle 7"/>
+          <p:cNvSpPr/>
+          <p:nvPr/>
+        </p:nvSpPr>
+        <p:spPr>
+          <a:xfrm>
             <a:off x="457200" y="1417320"/>
             <a:ext cx="3667658" cy="1569720"/>
           </a:xfrm>
           <a:prstGeom prst="roundRect">
             <a:avLst>
-              <a:gd name="adj" fmla="val 8000"/>
+              <a:gd name="adj" fmla="val 8155"/>
             </a:avLst>
           </a:prstGeom>
           <a:solidFill>
@@ -7900,6 +8989,7 @@
           <a:ln>
             <a:noFill/>
           </a:ln>
+          <a:effectLst/>
         </p:spPr>
         <p:style>
           <a:lnRef idx="1">
@@ -7925,7 +9015,7 @@
       </p:sp>
       <p:sp>
         <p:nvSpPr>
-          <p:cNvPr id="6" name="TextBox 5"/>
+          <p:cNvPr id="9" name="TextBox 8"/>
           <p:cNvSpPr txBox="1"/>
           <p:nvPr/>
         </p:nvSpPr>
@@ -7970,7 +9060,7 @@
       </p:sp>
       <p:sp>
         <p:nvSpPr>
-          <p:cNvPr id="7" name="TextBox 6"/>
+          <p:cNvPr id="10" name="TextBox 9"/>
           <p:cNvSpPr txBox="1"/>
           <p:nvPr/>
         </p:nvSpPr>
@@ -8060,7 +9150,7 @@
       </p:sp>
       <p:graphicFrame>
         <p:nvGraphicFramePr>
-          <p:cNvPr id="8" name="Chart 7"/>
+          <p:cNvPr id="11" name="Chart 10"/>
           <p:cNvGraphicFramePr>
             <a:graphicFrameLocks noGrp="1"/>
           </p:cNvGraphicFramePr>
@@ -8102,8 +9192,8 @@
         </p:nvSpPr>
         <p:spPr>
           <a:xfrm>
-            <a:off x="457200" y="320040"/>
-            <a:ext cx="11277295" cy="685800"/>
+            <a:off x="457200" y="182880"/>
+            <a:ext cx="11277295" cy="822960"/>
           </a:xfrm>
           <a:prstGeom prst="rect">
             <a:avLst/>
@@ -8163,9 +9253,132 @@
           </a:p>
         </p:txBody>
       </p:sp>
+      <p:sp>
+        <p:nvSpPr>
+          <p:cNvPr id="4" name="TextBox 3"/>
+          <p:cNvSpPr txBox="1"/>
+          <p:nvPr/>
+        </p:nvSpPr>
+        <p:spPr>
+          <a:xfrm>
+            <a:off x="7436815" y="6446520"/>
+            <a:ext cx="3657600" cy="274320"/>
+          </a:xfrm>
+          <a:prstGeom prst="rect">
+            <a:avLst/>
+          </a:prstGeom>
+          <a:noFill/>
+        </p:spPr>
+        <p:txBody>
+          <a:bodyPr wrap="square" anchor="t" lIns="45720" rIns="45720">
+            <a:spAutoFit/>
+          </a:bodyPr>
+          <a:lstStyle/>
+          <a:p>
+            <a:pPr algn="r"/>
+            <a:r>
+              <a:rPr sz="1000" b="1">
+                <a:solidFill>
+                  <a:srgbClr val="E07A5F"/>
+                </a:solidFill>
+                <a:latin typeface="Calibri"/>
+              </a:rPr>
+              <a:t>Campaign performance</a:t>
+            </a:r>
+          </a:p>
+        </p:txBody>
+      </p:sp>
+      <p:sp>
+        <p:nvSpPr>
+          <p:cNvPr id="5" name="Rectangle 4"/>
+          <p:cNvSpPr/>
+          <p:nvPr/>
+        </p:nvSpPr>
+        <p:spPr>
+          <a:xfrm>
+            <a:off x="0" y="6803136"/>
+            <a:ext cx="12191695" cy="54864"/>
+          </a:xfrm>
+          <a:prstGeom prst="rect">
+            <a:avLst/>
+          </a:prstGeom>
+          <a:solidFill>
+            <a:srgbClr val="F1F4F8"/>
+          </a:solidFill>
+          <a:ln>
+            <a:noFill/>
+          </a:ln>
+          <a:effectLst/>
+        </p:spPr>
+        <p:style>
+          <a:lnRef idx="1">
+            <a:schemeClr val="accent1"/>
+          </a:lnRef>
+          <a:fillRef idx="3">
+            <a:schemeClr val="accent1"/>
+          </a:fillRef>
+          <a:effectRef idx="2">
+            <a:schemeClr val="accent1"/>
+          </a:effectRef>
+          <a:fontRef idx="minor">
+            <a:schemeClr val="lt1"/>
+          </a:fontRef>
+        </p:style>
+        <p:txBody>
+          <a:bodyPr rtlCol="0" anchor="ctr"/>
+          <a:lstStyle/>
+          <a:p>
+            <a:pPr algn="ctr"/>
+          </a:p>
+        </p:txBody>
+      </p:sp>
+      <p:sp>
+        <p:nvSpPr>
+          <p:cNvPr id="6" name="Rectangle 5"/>
+          <p:cNvSpPr/>
+          <p:nvPr/>
+        </p:nvSpPr>
+        <p:spPr>
+          <a:xfrm>
+            <a:off x="0" y="6803136"/>
+            <a:ext cx="10837062" cy="54864"/>
+          </a:xfrm>
+          <a:prstGeom prst="rect">
+            <a:avLst/>
+          </a:prstGeom>
+          <a:solidFill>
+            <a:srgbClr val="E07A5F"/>
+          </a:solidFill>
+          <a:ln>
+            <a:noFill/>
+          </a:ln>
+          <a:effectLst/>
+        </p:spPr>
+        <p:style>
+          <a:lnRef idx="1">
+            <a:schemeClr val="accent1"/>
+          </a:lnRef>
+          <a:fillRef idx="3">
+            <a:schemeClr val="accent1"/>
+          </a:fillRef>
+          <a:effectRef idx="2">
+            <a:schemeClr val="accent1"/>
+          </a:effectRef>
+          <a:fontRef idx="minor">
+            <a:schemeClr val="lt1"/>
+          </a:fontRef>
+        </p:style>
+        <p:txBody>
+          <a:bodyPr rtlCol="0" anchor="ctr"/>
+          <a:lstStyle/>
+          <a:p>
+            <a:pPr algn="ctr"/>
+          </a:p>
+        </p:txBody>
+      </p:sp>
       <p:graphicFrame>
         <p:nvGraphicFramePr>
-          <p:cNvPr id="4" name="Chart 3"/>
+          <p:cNvPr id="7" name="Chart 6"/>
           <p:cNvGraphicFramePr>
             <a:graphicFrameLocks noGrp="1"/>
           </p:cNvGraphicFramePr>
@@ -8207,8 +9420,8 @@
         </p:nvSpPr>
         <p:spPr>
           <a:xfrm>
-            <a:off x="457200" y="320040"/>
-            <a:ext cx="11277295" cy="685800"/>
+            <a:off x="457200" y="182880"/>
+            <a:ext cx="11277295" cy="822960"/>
           </a:xfrm>
           <a:prstGeom prst="rect">
             <a:avLst/>
@@ -8270,14 +9483,49 @@
       </p:sp>
       <p:sp>
         <p:nvSpPr>
-          <p:cNvPr id="4" name="Rectangle 3"/>
+          <p:cNvPr id="4" name="TextBox 3"/>
+          <p:cNvSpPr txBox="1"/>
+          <p:nvPr/>
+        </p:nvSpPr>
+        <p:spPr>
+          <a:xfrm>
+            <a:off x="7436815" y="6446520"/>
+            <a:ext cx="3657600" cy="274320"/>
+          </a:xfrm>
+          <a:prstGeom prst="rect">
+            <a:avLst/>
+          </a:prstGeom>
+          <a:noFill/>
+        </p:spPr>
+        <p:txBody>
+          <a:bodyPr wrap="square" anchor="t" lIns="45720" rIns="45720">
+            <a:spAutoFit/>
+          </a:bodyPr>
+          <a:lstStyle/>
+          <a:p>
+            <a:pPr algn="r"/>
+            <a:r>
+              <a:rPr sz="1000" b="1">
+                <a:solidFill>
+                  <a:srgbClr val="E07A5F"/>
+                </a:solidFill>
+                <a:latin typeface="Calibri"/>
+              </a:rPr>
+              <a:t>Next steps</a:t>
+            </a:r>
+          </a:p>
+        </p:txBody>
+      </p:sp>
+      <p:sp>
+        <p:nvSpPr>
+          <p:cNvPr id="5" name="Rectangle 4"/>
           <p:cNvSpPr/>
           <p:nvPr/>
         </p:nvSpPr>
         <p:spPr>
           <a:xfrm>
-            <a:off x="457200" y="1417320"/>
-            <a:ext cx="11277295" cy="4892040"/>
+            <a:off x="0" y="6803136"/>
+            <a:ext cx="12191695" cy="54864"/>
           </a:xfrm>
           <a:prstGeom prst="rect">
             <a:avLst/>
@@ -8288,6 +9536,7 @@
           <a:ln>
             <a:noFill/>
           </a:ln>
+          <a:effectLst/>
         </p:spPr>
         <p:style>
           <a:lnRef idx="1">
@@ -8313,14 +9562,14 @@
       </p:sp>
       <p:sp>
         <p:nvSpPr>
-          <p:cNvPr id="5" name="Rectangle 4"/>
+          <p:cNvPr id="6" name="Rectangle 5"/>
           <p:cNvSpPr/>
           <p:nvPr/>
         </p:nvSpPr>
         <p:spPr>
           <a:xfrm>
-            <a:off x="457200" y="1417320"/>
-            <a:ext cx="73152" cy="4892040"/>
+            <a:off x="0" y="6803136"/>
+            <a:ext cx="12191695" cy="54864"/>
           </a:xfrm>
           <a:prstGeom prst="rect">
             <a:avLst/>
@@ -8331,6 +9580,7 @@
           <a:ln>
             <a:noFill/>
           </a:ln>
+          <a:effectLst/>
         </p:spPr>
         <p:style>
           <a:lnRef idx="1">
@@ -8356,14 +9606,67 @@
       </p:sp>
       <p:sp>
         <p:nvSpPr>
-          <p:cNvPr id="6" name="TextBox 5"/>
+          <p:cNvPr id="7" name="Pentagon 6"/>
+          <p:cNvSpPr/>
+          <p:nvPr/>
+        </p:nvSpPr>
+        <p:spPr>
+          <a:xfrm>
+            <a:off x="457200" y="1417320"/>
+            <a:ext cx="3966362" cy="731520"/>
+          </a:xfrm>
+          <a:prstGeom prst="homePlate">
+            <a:avLst/>
+          </a:prstGeom>
+          <a:solidFill>
+            <a:srgbClr val="E07A5F"/>
+          </a:solidFill>
+          <a:ln>
+            <a:noFill/>
+          </a:ln>
+          <a:effectLst/>
+        </p:spPr>
+        <p:style>
+          <a:lnRef idx="1">
+            <a:schemeClr val="accent1"/>
+          </a:lnRef>
+          <a:fillRef idx="3">
+            <a:schemeClr val="accent1"/>
+          </a:fillRef>
+          <a:effectRef idx="2">
+            <a:schemeClr val="accent1"/>
+          </a:effectRef>
+          <a:fontRef idx="minor">
+            <a:schemeClr val="lt1"/>
+          </a:fontRef>
+        </p:style>
+        <p:txBody>
+          <a:bodyPr rtlCol="0" anchor="ctr" lIns="411480" rIns="219456" wrap="square"/>
+          <a:lstStyle/>
+          <a:p>
+            <a:pPr algn="ctr"/>
+            <a:r>
+              <a:rPr sz="1500" b="1">
+                <a:solidFill>
+                  <a:srgbClr val="FFFFFF"/>
+                </a:solidFill>
+                <a:latin typeface="Calibri"/>
+              </a:rPr>
+              <a:t>Q1 FY27</a:t>
+            </a:r>
+          </a:p>
+        </p:txBody>
+      </p:sp>
+      <p:sp>
+        <p:nvSpPr>
+          <p:cNvPr id="8" name="TextBox 7"/>
           <p:cNvSpPr txBox="1"/>
           <p:nvPr/>
         </p:nvSpPr>
         <p:spPr>
           <a:xfrm>
-            <a:off x="731520" y="1600200"/>
-            <a:ext cx="10820095" cy="4526280"/>
+            <a:off x="640080" y="2331720"/>
+            <a:ext cx="3554882" cy="1695615"/>
           </a:xfrm>
           <a:prstGeom prst="rect">
             <a:avLst/>
@@ -8371,102 +9674,586 @@
           <a:noFill/>
         </p:spPr>
         <p:txBody>
+          <a:bodyPr wrap="square" anchor="t" lIns="45720" rIns="45720">
+            <a:spAutoFit/>
+          </a:bodyPr>
+          <a:lstStyle/>
+          <a:p>
+            <a:pPr algn="l">
+              <a:spcAft>
+                <a:spcPts val="480"/>
+              </a:spcAft>
+            </a:pPr>
+            <a:r>
+              <a:rPr sz="1600" b="1">
+                <a:solidFill>
+                  <a:srgbClr val="1F3A5F"/>
+                </a:solidFill>
+                <a:latin typeface="Calibri"/>
+              </a:rPr>
+              <a:t>Rebalance spend</a:t>
+            </a:r>
+          </a:p>
+          <a:p>
+            <a:pPr algn="l">
+              <a:spcAft>
+                <a:spcPts val="390"/>
+              </a:spcAft>
+            </a:pPr>
+            <a:r>
+              <a:rPr sz="1300">
+                <a:solidFill>
+                  <a:srgbClr val="6C757D"/>
+                </a:solidFill>
+                <a:latin typeface="Calibri"/>
+              </a:rPr>
+              <a:t>Shift </a:t>
+            </a:r>
+            <a:r>
+              <a:rPr sz="1300" b="1">
+                <a:solidFill>
+                  <a:srgbClr val="E07A5F"/>
+                </a:solidFill>
+                <a:latin typeface="Calibri"/>
+              </a:rPr>
+              <a:t>15%</a:t>
+            </a:r>
+            <a:r>
+              <a:rPr sz="1300">
+                <a:solidFill>
+                  <a:srgbClr val="6C757D"/>
+                </a:solidFill>
+                <a:latin typeface="Calibri"/>
+              </a:rPr>
+              <a:t> of trade-show budget into online retargeting</a:t>
+            </a:r>
+          </a:p>
+        </p:txBody>
+      </p:sp>
+      <p:sp>
+        <p:nvSpPr>
+          <p:cNvPr id="9" name="Chevron 8"/>
+          <p:cNvSpPr/>
+          <p:nvPr/>
+        </p:nvSpPr>
+        <p:spPr>
+          <a:xfrm>
+            <a:off x="4112666" y="1417320"/>
+            <a:ext cx="3966362" cy="731520"/>
+          </a:xfrm>
+          <a:prstGeom prst="chevron">
+            <a:avLst/>
+          </a:prstGeom>
+          <a:solidFill>
+            <a:srgbClr val="C5CDD6"/>
+          </a:solidFill>
+          <a:ln>
+            <a:noFill/>
+          </a:ln>
+          <a:effectLst/>
+        </p:spPr>
+        <p:style>
+          <a:lnRef idx="1">
+            <a:schemeClr val="accent1"/>
+          </a:lnRef>
+          <a:fillRef idx="3">
+            <a:schemeClr val="accent1"/>
+          </a:fillRef>
+          <a:effectRef idx="2">
+            <a:schemeClr val="accent1"/>
+          </a:effectRef>
+          <a:fontRef idx="minor">
+            <a:schemeClr val="lt1"/>
+          </a:fontRef>
+        </p:style>
+        <p:txBody>
+          <a:bodyPr rtlCol="0" anchor="ctr" lIns="411480" rIns="219456" wrap="square"/>
+          <a:lstStyle/>
+          <a:p>
+            <a:pPr algn="ctr"/>
+            <a:r>
+              <a:rPr sz="1500" b="1">
+                <a:solidFill>
+                  <a:srgbClr val="1F3A5F"/>
+                </a:solidFill>
+                <a:latin typeface="Calibri"/>
+              </a:rPr>
+              <a:t>Q2 FY27</a:t>
+            </a:r>
+          </a:p>
+        </p:txBody>
+      </p:sp>
+      <p:sp>
+        <p:nvSpPr>
+          <p:cNvPr id="10" name="TextBox 9"/>
+          <p:cNvSpPr txBox="1"/>
+          <p:nvPr/>
+        </p:nvSpPr>
+        <p:spPr>
+          <a:xfrm>
+            <a:off x="4295546" y="2331720"/>
+            <a:ext cx="3554882" cy="1695615"/>
+          </a:xfrm>
+          <a:prstGeom prst="rect">
+            <a:avLst/>
+          </a:prstGeom>
+          <a:noFill/>
+        </p:spPr>
+        <p:txBody>
+          <a:bodyPr wrap="square" anchor="t" lIns="45720" rIns="45720">
+            <a:spAutoFit/>
+          </a:bodyPr>
+          <a:lstStyle/>
+          <a:p>
+            <a:pPr algn="l">
+              <a:spcAft>
+                <a:spcPts val="480"/>
+              </a:spcAft>
+            </a:pPr>
+            <a:r>
+              <a:rPr sz="1600" b="1">
+                <a:solidFill>
+                  <a:srgbClr val="1F3A5F"/>
+                </a:solidFill>
+                <a:latin typeface="Calibri"/>
+              </a:rPr>
+              <a:t>Grow Pro in the South</a:t>
+            </a:r>
+          </a:p>
+          <a:p>
+            <a:pPr algn="l">
+              <a:spcAft>
+                <a:spcPts val="390"/>
+              </a:spcAft>
+            </a:pPr>
+            <a:r>
+              <a:rPr sz="1300">
+                <a:solidFill>
+                  <a:srgbClr val="6C757D"/>
+                </a:solidFill>
+                <a:latin typeface="Calibri"/>
+              </a:rPr>
+              <a:t>Expand the Pro tier push into the South region</a:t>
+            </a:r>
+          </a:p>
+        </p:txBody>
+      </p:sp>
+      <p:sp>
+        <p:nvSpPr>
+          <p:cNvPr id="11" name="Chevron 10"/>
+          <p:cNvSpPr/>
+          <p:nvPr/>
+        </p:nvSpPr>
+        <p:spPr>
+          <a:xfrm>
+            <a:off x="7768132" y="1417320"/>
+            <a:ext cx="3966362" cy="731520"/>
+          </a:xfrm>
+          <a:prstGeom prst="chevron">
+            <a:avLst/>
+          </a:prstGeom>
+          <a:solidFill>
+            <a:srgbClr val="C5CDD6"/>
+          </a:solidFill>
+          <a:ln>
+            <a:noFill/>
+          </a:ln>
+          <a:effectLst/>
+        </p:spPr>
+        <p:style>
+          <a:lnRef idx="1">
+            <a:schemeClr val="accent1"/>
+          </a:lnRef>
+          <a:fillRef idx="3">
+            <a:schemeClr val="accent1"/>
+          </a:fillRef>
+          <a:effectRef idx="2">
+            <a:schemeClr val="accent1"/>
+          </a:effectRef>
+          <a:fontRef idx="minor">
+            <a:schemeClr val="lt1"/>
+          </a:fontRef>
+        </p:style>
+        <p:txBody>
+          <a:bodyPr rtlCol="0" anchor="ctr" lIns="411480" rIns="219456" wrap="square"/>
+          <a:lstStyle/>
+          <a:p>
+            <a:pPr algn="ctr"/>
+            <a:r>
+              <a:rPr sz="1500" b="1">
+                <a:solidFill>
+                  <a:srgbClr val="1F3A5F"/>
+                </a:solidFill>
+                <a:latin typeface="Calibri"/>
+              </a:rPr>
+              <a:t>Q3 FY27</a:t>
+            </a:r>
+          </a:p>
+        </p:txBody>
+      </p:sp>
+      <p:sp>
+        <p:nvSpPr>
+          <p:cNvPr id="12" name="TextBox 11"/>
+          <p:cNvSpPr txBox="1"/>
+          <p:nvPr/>
+        </p:nvSpPr>
+        <p:spPr>
+          <a:xfrm>
+            <a:off x="7951012" y="2331720"/>
+            <a:ext cx="3554882" cy="1695615"/>
+          </a:xfrm>
+          <a:prstGeom prst="rect">
+            <a:avLst/>
+          </a:prstGeom>
+          <a:noFill/>
+        </p:spPr>
+        <p:txBody>
+          <a:bodyPr wrap="square" anchor="t" lIns="45720" rIns="45720">
+            <a:spAutoFit/>
+          </a:bodyPr>
+          <a:lstStyle/>
+          <a:p>
+            <a:pPr algn="l">
+              <a:spcAft>
+                <a:spcPts val="480"/>
+              </a:spcAft>
+            </a:pPr>
+            <a:r>
+              <a:rPr sz="1600" b="1">
+                <a:solidFill>
+                  <a:srgbClr val="1F3A5F"/>
+                </a:solidFill>
+                <a:latin typeface="Calibri"/>
+              </a:rPr>
+              <a:t>Reset targets</a:t>
+            </a:r>
+          </a:p>
+          <a:p>
+            <a:pPr algn="l">
+              <a:spcAft>
+                <a:spcPts val="390"/>
+              </a:spcAft>
+            </a:pPr>
+            <a:r>
+              <a:rPr sz="1300">
+                <a:solidFill>
+                  <a:srgbClr val="6C757D"/>
+                </a:solidFill>
+                <a:latin typeface="Calibri"/>
+              </a:rPr>
+              <a:t>Re-baseline FY27 targets off the Q4 run-rate</a:t>
+            </a:r>
+          </a:p>
+        </p:txBody>
+      </p:sp>
+      <p:sp>
+        <p:nvSpPr>
+          <p:cNvPr id="13" name="Rounded Rectangle 12"/>
+          <p:cNvSpPr/>
+          <p:nvPr/>
+        </p:nvSpPr>
+        <p:spPr>
+          <a:xfrm>
+            <a:off x="457200" y="4301655"/>
+            <a:ext cx="3606698" cy="2007704"/>
+          </a:xfrm>
+          <a:prstGeom prst="roundRect">
+            <a:avLst>
+              <a:gd name="adj" fmla="val 6376"/>
+            </a:avLst>
+          </a:prstGeom>
+          <a:solidFill>
+            <a:srgbClr val="FBFCFD"/>
+          </a:solidFill>
+          <a:ln w="12700">
+            <a:solidFill>
+              <a:srgbClr val="C5CDD6"/>
+            </a:solidFill>
+          </a:ln>
+          <a:effectLst/>
+        </p:spPr>
+        <p:style>
+          <a:lnRef idx="1">
+            <a:schemeClr val="accent1"/>
+          </a:lnRef>
+          <a:fillRef idx="3">
+            <a:schemeClr val="accent1"/>
+          </a:fillRef>
+          <a:effectRef idx="2">
+            <a:schemeClr val="accent1"/>
+          </a:effectRef>
+          <a:fontRef idx="minor">
+            <a:schemeClr val="lt1"/>
+          </a:fontRef>
+        </p:style>
+        <p:txBody>
+          <a:bodyPr rtlCol="0" anchor="ctr"/>
+          <a:lstStyle/>
+          <a:p>
+            <a:pPr algn="ctr"/>
+          </a:p>
+        </p:txBody>
+      </p:sp>
+      <p:sp>
+        <p:nvSpPr>
+          <p:cNvPr id="14" name="TextBox 13"/>
+          <p:cNvSpPr txBox="1"/>
+          <p:nvPr/>
+        </p:nvSpPr>
+        <p:spPr>
+          <a:xfrm>
+            <a:off x="640080" y="4393095"/>
+            <a:ext cx="3240938" cy="1824824"/>
+          </a:xfrm>
+          <a:prstGeom prst="rect">
+            <a:avLst/>
+          </a:prstGeom>
+          <a:noFill/>
+        </p:spPr>
+        <p:txBody>
           <a:bodyPr wrap="square" anchor="ctr" lIns="45720" rIns="45720">
             <a:spAutoFit/>
           </a:bodyPr>
           <a:lstStyle/>
           <a:p>
-            <a:pPr>
-              <a:spcAft>
-                <a:spcPts val="800"/>
-              </a:spcAft>
-            </a:pPr>
-            <a:r>
-              <a:rPr sz="2400" b="1">
-                <a:solidFill>
-                  <a:srgbClr val="1F3A5F"/>
+            <a:r>
+              <a:rPr sz="1200">
+                <a:solidFill>
+                  <a:srgbClr val="6C757D"/>
                 </a:solidFill>
                 <a:latin typeface="Calibri"/>
               </a:rPr>
-              <a:t>Recommendations</a:t>
-            </a:r>
-          </a:p>
-          <a:p>
-            <a:pPr marL="256032" indent="-256032">
-              <a:spcAft>
-                <a:spcPts val="1000"/>
-              </a:spcAft>
-              <a:buClr>
-                <a:srgbClr val="E07A5F"/>
-              </a:buClr>
-              <a:buChar char="•"/>
-            </a:pPr>
-            <a:r>
-              <a:rPr sz="2200">
-                <a:solidFill>
-                  <a:srgbClr val="2B2D42"/>
+              <a:t>Trade Show return on spend</a:t>
+            </a:r>
+          </a:p>
+          <a:p>
+            <a:r>
+              <a:rPr sz="3000" b="1">
+                <a:solidFill>
+                  <a:srgbClr val="1F3A5F"/>
                 </a:solidFill>
                 <a:latin typeface="Calibri"/>
               </a:rPr>
-              <a:t>Shift </a:t>
-            </a:r>
-            <a:r>
-              <a:rPr sz="2200" b="1">
-                <a:solidFill>
-                  <a:srgbClr val="E07A5F"/>
+              <a:t>2.2x</a:t>
+            </a:r>
+          </a:p>
+          <a:p>
+            <a:r>
+              <a:rPr sz="1200">
+                <a:solidFill>
+                  <a:srgbClr val="6C757D"/>
                 </a:solidFill>
                 <a:latin typeface="Calibri"/>
               </a:rPr>
-              <a:t>15%</a:t>
-            </a:r>
-            <a:r>
-              <a:rPr sz="2200">
-                <a:solidFill>
-                  <a:srgbClr val="2B2D42"/>
+              <a:t>the weakest campaign</a:t>
+            </a:r>
+          </a:p>
+        </p:txBody>
+      </p:sp>
+      <p:sp>
+        <p:nvSpPr>
+          <p:cNvPr id="15" name="Rounded Rectangle 14"/>
+          <p:cNvSpPr/>
+          <p:nvPr/>
+        </p:nvSpPr>
+        <p:spPr>
+          <a:xfrm>
+            <a:off x="4292498" y="4301655"/>
+            <a:ext cx="3606698" cy="2007704"/>
+          </a:xfrm>
+          <a:prstGeom prst="roundRect">
+            <a:avLst>
+              <a:gd name="adj" fmla="val 6376"/>
+            </a:avLst>
+          </a:prstGeom>
+          <a:solidFill>
+            <a:srgbClr val="FBFCFD"/>
+          </a:solidFill>
+          <a:ln w="12700">
+            <a:solidFill>
+              <a:srgbClr val="C5CDD6"/>
+            </a:solidFill>
+          </a:ln>
+          <a:effectLst/>
+        </p:spPr>
+        <p:style>
+          <a:lnRef idx="1">
+            <a:schemeClr val="accent1"/>
+          </a:lnRef>
+          <a:fillRef idx="3">
+            <a:schemeClr val="accent1"/>
+          </a:fillRef>
+          <a:effectRef idx="2">
+            <a:schemeClr val="accent1"/>
+          </a:effectRef>
+          <a:fontRef idx="minor">
+            <a:schemeClr val="lt1"/>
+          </a:fontRef>
+        </p:style>
+        <p:txBody>
+          <a:bodyPr rtlCol="0" anchor="ctr"/>
+          <a:lstStyle/>
+          <a:p>
+            <a:pPr algn="ctr"/>
+          </a:p>
+        </p:txBody>
+      </p:sp>
+      <p:sp>
+        <p:nvSpPr>
+          <p:cNvPr id="16" name="TextBox 15"/>
+          <p:cNvSpPr txBox="1"/>
+          <p:nvPr/>
+        </p:nvSpPr>
+        <p:spPr>
+          <a:xfrm>
+            <a:off x="4475378" y="4393095"/>
+            <a:ext cx="3240938" cy="1824824"/>
+          </a:xfrm>
+          <a:prstGeom prst="rect">
+            <a:avLst/>
+          </a:prstGeom>
+          <a:noFill/>
+        </p:spPr>
+        <p:txBody>
+          <a:bodyPr wrap="square" anchor="ctr" lIns="45720" rIns="45720">
+            <a:spAutoFit/>
+          </a:bodyPr>
+          <a:lstStyle/>
+          <a:p>
+            <a:r>
+              <a:rPr sz="1200">
+                <a:solidFill>
+                  <a:srgbClr val="6C757D"/>
                 </a:solidFill>
                 <a:latin typeface="Calibri"/>
               </a:rPr>
-              <a:t> of trade-show budget into online retargeting</a:t>
-            </a:r>
-          </a:p>
-          <a:p>
-            <a:pPr marL="256032" indent="-256032">
-              <a:spcAft>
-                <a:spcPts val="1000"/>
-              </a:spcAft>
-              <a:buClr>
-                <a:srgbClr val="E07A5F"/>
-              </a:buClr>
-              <a:buChar char="•"/>
-            </a:pPr>
-            <a:r>
-              <a:rPr sz="2200">
-                <a:solidFill>
-                  <a:srgbClr val="2B2D42"/>
+              <a:t>South revenue</a:t>
+            </a:r>
+          </a:p>
+          <a:p>
+            <a:r>
+              <a:rPr sz="3000" b="1">
+                <a:solidFill>
+                  <a:srgbClr val="1F3A5F"/>
                 </a:solidFill>
                 <a:latin typeface="Calibri"/>
               </a:rPr>
-              <a:t>Expand the Pro tier push into the South region</a:t>
-            </a:r>
-          </a:p>
-          <a:p>
-            <a:pPr marL="256032" indent="-256032">
-              <a:spcAft>
-                <a:spcPts val="1000"/>
-              </a:spcAft>
-              <a:buClr>
-                <a:srgbClr val="E07A5F"/>
-              </a:buClr>
-              <a:buChar char="•"/>
-            </a:pPr>
-            <a:r>
-              <a:rPr sz="2200">
-                <a:solidFill>
-                  <a:srgbClr val="2B2D42"/>
+              <a:t>$488,000</a:t>
+            </a:r>
+          </a:p>
+          <a:p>
+            <a:r>
+              <a:rPr sz="1200">
+                <a:solidFill>
+                  <a:srgbClr val="6C757D"/>
                 </a:solidFill>
                 <a:latin typeface="Calibri"/>
               </a:rPr>
-              <a:t>Re-baseline FY27 targets off the Q4 run-rate</a:t>
+              <a:t>the smallest region</a:t>
+            </a:r>
+          </a:p>
+        </p:txBody>
+      </p:sp>
+      <p:sp>
+        <p:nvSpPr>
+          <p:cNvPr id="17" name="Rounded Rectangle 16"/>
+          <p:cNvSpPr/>
+          <p:nvPr/>
+        </p:nvSpPr>
+        <p:spPr>
+          <a:xfrm>
+            <a:off x="8127796" y="4301655"/>
+            <a:ext cx="3606698" cy="2007704"/>
+          </a:xfrm>
+          <a:prstGeom prst="roundRect">
+            <a:avLst>
+              <a:gd name="adj" fmla="val 6376"/>
+            </a:avLst>
+          </a:prstGeom>
+          <a:solidFill>
+            <a:srgbClr val="FBFCFD"/>
+          </a:solidFill>
+          <a:ln w="12700">
+            <a:solidFill>
+              <a:srgbClr val="C5CDD6"/>
+            </a:solidFill>
+          </a:ln>
+          <a:effectLst/>
+        </p:spPr>
+        <p:style>
+          <a:lnRef idx="1">
+            <a:schemeClr val="accent1"/>
+          </a:lnRef>
+          <a:fillRef idx="3">
+            <a:schemeClr val="accent1"/>
+          </a:fillRef>
+          <a:effectRef idx="2">
+            <a:schemeClr val="accent1"/>
+          </a:effectRef>
+          <a:fontRef idx="minor">
+            <a:schemeClr val="lt1"/>
+          </a:fontRef>
+        </p:style>
+        <p:txBody>
+          <a:bodyPr rtlCol="0" anchor="ctr"/>
+          <a:lstStyle/>
+          <a:p>
+            <a:pPr algn="ctr"/>
+          </a:p>
+        </p:txBody>
+      </p:sp>
+      <p:sp>
+        <p:nvSpPr>
+          <p:cNvPr id="18" name="TextBox 17"/>
+          <p:cNvSpPr txBox="1"/>
+          <p:nvPr/>
+        </p:nvSpPr>
+        <p:spPr>
+          <a:xfrm>
+            <a:off x="8310676" y="4393095"/>
+            <a:ext cx="3240938" cy="1824824"/>
+          </a:xfrm>
+          <a:prstGeom prst="rect">
+            <a:avLst/>
+          </a:prstGeom>
+          <a:noFill/>
+        </p:spPr>
+        <p:txBody>
+          <a:bodyPr wrap="square" anchor="ctr" lIns="45720" rIns="45720">
+            <a:spAutoFit/>
+          </a:bodyPr>
+          <a:lstStyle/>
+          <a:p>
+            <a:r>
+              <a:rPr sz="1200">
+                <a:solidFill>
+                  <a:srgbClr val="6C757D"/>
+                </a:solidFill>
+                <a:latin typeface="Calibri"/>
+              </a:rPr>
+              <a:t>Q4 revenue</a:t>
+            </a:r>
+          </a:p>
+          <a:p>
+            <a:r>
+              <a:rPr sz="3000" b="1">
+                <a:solidFill>
+                  <a:srgbClr val="1F3A5F"/>
+                </a:solidFill>
+                <a:latin typeface="Calibri"/>
+              </a:rPr>
+              <a:t>$777,900</a:t>
+            </a:r>
+          </a:p>
+          <a:p>
+            <a:r>
+              <a:rPr sz="1200">
+                <a:solidFill>
+                  <a:srgbClr val="6C757D"/>
+                </a:solidFill>
+                <a:latin typeface="Calibri"/>
+              </a:rPr>
+              <a:t>the new quarterly run-rate</a:t>
             </a:r>
           </a:p>
         </p:txBody>

</xml_diff>

<commit_message>
Rebuild demo decks and add recipes deck
Co-Authored-By: Claude Sonnet 5.5 <noreply@anthropic.com>
</commit_message>
<xml_diff>
--- a/out/demo.pptx
+++ b/out/demo.pptx
@@ -474,6 +474,29 @@
               <a:srgbClr val="1F3A5F"/>
             </a:solidFill>
           </c:spPr>
+          <c:dLbls>
+            <c:numFmt formatCode="$#,##0,&quot;K&quot;" sourceLinked="0"/>
+            <c:txPr>
+              <a:bodyPr/>
+              <a:lstStyle/>
+              <a:p>
+                <a:pPr>
+                  <a:defRPr sz="1000">
+                    <a:solidFill>
+                      <a:srgbClr val="FFFFFF"/>
+                    </a:solidFill>
+                  </a:defRPr>
+                </a:pPr>
+              </a:p>
+            </c:txPr>
+            <c:showLegendKey val="0"/>
+            <c:showVal val="1"/>
+            <c:showCatName val="0"/>
+            <c:showSerName val="0"/>
+            <c:showPercent val="0"/>
+            <c:showBubbleSize val="0"/>
+            <c:showLeaderLines val="1"/>
+          </c:dLbls>
           <c:cat>
             <c:strRef>
               <c:f>Sheet1!$A$2:$A$5</c:f>
@@ -535,6 +558,29 @@
               <a:srgbClr val="E07A5F"/>
             </a:solidFill>
           </c:spPr>
+          <c:dLbls>
+            <c:numFmt formatCode="$#,##0,&quot;K&quot;" sourceLinked="0"/>
+            <c:txPr>
+              <a:bodyPr/>
+              <a:lstStyle/>
+              <a:p>
+                <a:pPr>
+                  <a:defRPr sz="1000">
+                    <a:solidFill>
+                      <a:srgbClr val="2B2D42"/>
+                    </a:solidFill>
+                  </a:defRPr>
+                </a:pPr>
+              </a:p>
+            </c:txPr>
+            <c:showLegendKey val="0"/>
+            <c:showVal val="1"/>
+            <c:showCatName val="0"/>
+            <c:showSerName val="0"/>
+            <c:showPercent val="0"/>
+            <c:showBubbleSize val="0"/>
+            <c:showLeaderLines val="1"/>
+          </c:dLbls>
           <c:cat>
             <c:strRef>
               <c:f>Sheet1!$A$2:$A$5</c:f>
@@ -596,6 +642,29 @@
               <a:srgbClr val="3D8BD3"/>
             </a:solidFill>
           </c:spPr>
+          <c:dLbls>
+            <c:numFmt formatCode="$#,##0,&quot;K&quot;" sourceLinked="0"/>
+            <c:txPr>
+              <a:bodyPr/>
+              <a:lstStyle/>
+              <a:p>
+                <a:pPr>
+                  <a:defRPr sz="1000">
+                    <a:solidFill>
+                      <a:srgbClr val="FFFFFF"/>
+                    </a:solidFill>
+                  </a:defRPr>
+                </a:pPr>
+              </a:p>
+            </c:txPr>
+            <c:showLegendKey val="0"/>
+            <c:showVal val="1"/>
+            <c:showCatName val="0"/>
+            <c:showSerName val="0"/>
+            <c:showPercent val="0"/>
+            <c:showBubbleSize val="0"/>
+            <c:showLeaderLines val="1"/>
+          </c:dLbls>
           <c:cat>
             <c:strRef>
               <c:f>Sheet1!$A$2:$A$5</c:f>
@@ -910,7 +979,7 @@
           </a:ln>
         </c:spPr>
         <c:crossAx val="-2068027336"/>
-        <c:crosses val="autoZero"/>
+        <c:crosses val="max"/>
       </c:valAx>
     </c:plotArea>
     <c:dispBlanksAs val="gap"/>
@@ -1012,6 +1081,111 @@
               </a:solidFill>
             </c:spPr>
           </c:dPt>
+          <c:dLbls>
+            <c:dLbl>
+              <c:idx val="0"/>
+              <c:spPr/>
+              <c:numFmt formatCode="0%" sourceLinked="0"/>
+              <c:txPr>
+                <a:bodyPr/>
+                <a:lstStyle/>
+                <a:p>
+                  <a:pPr>
+                    <a:defRPr sz="1000">
+                      <a:solidFill>
+                        <a:srgbClr val="FFFFFF"/>
+                      </a:solidFill>
+                    </a:defRPr>
+                  </a:pPr>
+                </a:p>
+              </c:txPr>
+              <c:showLegendKey val="0"/>
+              <c:showVal val="1"/>
+              <c:showCatName val="0"/>
+              <c:showSerName val="0"/>
+              <c:showPercent val="0"/>
+              <c:showBubbleSize val="0"/>
+            </c:dLbl>
+            <c:dLbl>
+              <c:idx val="1"/>
+              <c:spPr/>
+              <c:numFmt formatCode="0%" sourceLinked="0"/>
+              <c:txPr>
+                <a:bodyPr/>
+                <a:lstStyle/>
+                <a:p>
+                  <a:pPr>
+                    <a:defRPr sz="1000">
+                      <a:solidFill>
+                        <a:srgbClr val="2B2D42"/>
+                      </a:solidFill>
+                    </a:defRPr>
+                  </a:pPr>
+                </a:p>
+              </c:txPr>
+              <c:showLegendKey val="0"/>
+              <c:showVal val="1"/>
+              <c:showCatName val="0"/>
+              <c:showSerName val="0"/>
+              <c:showPercent val="0"/>
+              <c:showBubbleSize val="0"/>
+            </c:dLbl>
+            <c:dLbl>
+              <c:idx val="2"/>
+              <c:spPr/>
+              <c:numFmt formatCode="0%" sourceLinked="0"/>
+              <c:txPr>
+                <a:bodyPr/>
+                <a:lstStyle/>
+                <a:p>
+                  <a:pPr>
+                    <a:defRPr sz="1000">
+                      <a:solidFill>
+                        <a:srgbClr val="FFFFFF"/>
+                      </a:solidFill>
+                    </a:defRPr>
+                  </a:pPr>
+                </a:p>
+              </c:txPr>
+              <c:showLegendKey val="0"/>
+              <c:showVal val="1"/>
+              <c:showCatName val="0"/>
+              <c:showSerName val="0"/>
+              <c:showPercent val="0"/>
+              <c:showBubbleSize val="0"/>
+            </c:dLbl>
+            <c:dLbl>
+              <c:idx val="3"/>
+              <c:spPr/>
+              <c:numFmt formatCode="0%" sourceLinked="0"/>
+              <c:txPr>
+                <a:bodyPr/>
+                <a:lstStyle/>
+                <a:p>
+                  <a:pPr>
+                    <a:defRPr sz="1000">
+                      <a:solidFill>
+                        <a:srgbClr val="2B2D42"/>
+                      </a:solidFill>
+                    </a:defRPr>
+                  </a:pPr>
+                </a:p>
+              </c:txPr>
+              <c:showLegendKey val="0"/>
+              <c:showVal val="1"/>
+              <c:showCatName val="0"/>
+              <c:showSerName val="0"/>
+              <c:showPercent val="0"/>
+              <c:showBubbleSize val="0"/>
+            </c:dLbl>
+            <c:showLegendKey val="0"/>
+            <c:showVal val="0"/>
+            <c:showCatName val="0"/>
+            <c:showSerName val="0"/>
+            <c:showPercent val="0"/>
+            <c:showBubbleSize val="0"/>
+            <c:showLeaderLines val="1"/>
+          </c:dLbls>
           <c:cat>
             <c:strRef>
               <c:f>Sheet1!$A$2:$A$5</c:f>
@@ -1870,7 +2044,7 @@
           </a:ln>
         </c:spPr>
         <c:crossAx val="-2068027336"/>
-        <c:crosses val="autoZero"/>
+        <c:crosses val="max"/>
       </c:valAx>
     </c:plotArea>
     <c:dispBlanksAs val="gap"/>

</xml_diff>